<commit_message>
Rebuild 28 PPTs: inquiry slides, cultural connections (China/Korea/Germany), video recommendations, no LearnLattice
</commit_message>
<xml_diff>
--- a/static/ppts/G6_Math_Capacity.pptx
+++ b/static/ppts/G6_Math_Capacity.pptx
@@ -10,9 +10,12 @@
     <p:sldId id="258" r:id="rId4"/>
     <p:sldId id="259" r:id="rId5"/>
     <p:sldId id="260" r:id="rId6"/>
+    <p:sldId id="261" r:id="rId7"/>
+    <p:sldId id="262" r:id="rId8"/>
+    <p:sldId id="263" r:id="rId9"/>
   </p:sldIdLst>
   <p:notesMasterIdLst>
-    <p:notesMasterId r:id="rId7"/>
+    <p:notesMasterId r:id="rId10"/>
   </p:notesMasterIdLst>
   <p:sldSz cx="9144000" cy="5143500"/>
   <p:notesSz cx="5143500" cy="9144000"/>
@@ -882,6 +885,270 @@
             <a:fld id="{F7021451-1387-4CA6-816F-3879F97B5CBC}" type="slidenum">
               <a:rPr lang="en-US"/>
               <a:t>5</a:t>
+            </a:fld>
+            <a:endParaRPr lang="en-US"/>
+          </a:p>
+        </p:txBody>
+      </p:sp>
+    </p:spTree>
+    <p:extLst>
+      <p:ext uri="{BB962C8B-B14F-4D97-AF65-F5344CB8AC3E}">
+        <p14:creationId xmlns:p14="http://schemas.microsoft.com/office/powerpoint/2010/main" val="1024086991"/>
+      </p:ext>
+    </p:extLst>
+  </p:cSld>
+  <p:clrMapOvr>
+    <a:masterClrMapping/>
+  </p:clrMapOvr>
+</p:notes>
+</file>
+
+<file path=ppt/notesSlides/notesSlide6.xml><?xml version="1.0" encoding="utf-8"?>
+<p:notes xmlns:a="http://schemas.openxmlformats.org/drawingml/2006/main" xmlns:r="http://schemas.openxmlformats.org/officeDocument/2006/relationships" xmlns:p="http://schemas.openxmlformats.org/presentationml/2006/main">
+  <p:cSld>
+    <p:spTree>
+      <p:nvGrpSpPr>
+        <p:cNvPr id="1" name=""/>
+        <p:cNvGrpSpPr/>
+        <p:nvPr/>
+      </p:nvGrpSpPr>
+      <p:grpSpPr>
+        <a:xfrm>
+          <a:off x="0" y="0"/>
+          <a:ext cx="0" cy="0"/>
+          <a:chOff x="0" y="0"/>
+          <a:chExt cx="0" cy="0"/>
+        </a:xfrm>
+      </p:grpSpPr>
+      <p:sp>
+        <p:nvSpPr>
+          <p:cNvPr id="2" name="Slide Image Placeholder 1"/>
+          <p:cNvSpPr>
+            <a:spLocks noGrp="1" noRot="1" noChangeAspect="1"/>
+          </p:cNvSpPr>
+          <p:nvPr>
+            <p:ph type="sldImg"/>
+          </p:nvPr>
+        </p:nvSpPr>
+        <p:spPr/>
+      </p:sp>
+      <p:sp>
+        <p:nvSpPr>
+          <p:cNvPr id="3" name="Notes Placeholder 2"/>
+          <p:cNvSpPr>
+            <a:spLocks noGrp="1"/>
+          </p:cNvSpPr>
+          <p:nvPr>
+            <p:ph type="body" idx="1"/>
+          </p:nvPr>
+        </p:nvSpPr>
+        <p:spPr/>
+        <p:txBody>
+          <a:bodyPr/>
+          <a:lstStyle/>
+          <a:p>
+            <a:r>
+              <a:rPr lang="en-US" dirty="0"/>
+              <a:t/>
+            </a:r>
+            <a:endParaRPr lang="en-US" dirty="0"/>
+          </a:p>
+        </p:txBody>
+      </p:sp>
+      <p:sp>
+        <p:nvSpPr>
+          <p:cNvPr id="4" name="Slide Number Placeholder 3"/>
+          <p:cNvSpPr>
+            <a:spLocks noGrp="1"/>
+          </p:cNvSpPr>
+          <p:nvPr>
+            <p:ph type="sldNum" sz="quarter" idx="10"/>
+          </p:nvPr>
+        </p:nvSpPr>
+        <p:spPr/>
+        <p:txBody>
+          <a:bodyPr/>
+          <a:lstStyle/>
+          <a:p>
+            <a:fld id="{F7021451-1387-4CA6-816F-3879F97B5CBC}" type="slidenum">
+              <a:rPr lang="en-US"/>
+              <a:t>6</a:t>
+            </a:fld>
+            <a:endParaRPr lang="en-US"/>
+          </a:p>
+        </p:txBody>
+      </p:sp>
+    </p:spTree>
+    <p:extLst>
+      <p:ext uri="{BB962C8B-B14F-4D97-AF65-F5344CB8AC3E}">
+        <p14:creationId xmlns:p14="http://schemas.microsoft.com/office/powerpoint/2010/main" val="1024086991"/>
+      </p:ext>
+    </p:extLst>
+  </p:cSld>
+  <p:clrMapOvr>
+    <a:masterClrMapping/>
+  </p:clrMapOvr>
+</p:notes>
+</file>
+
+<file path=ppt/notesSlides/notesSlide7.xml><?xml version="1.0" encoding="utf-8"?>
+<p:notes xmlns:a="http://schemas.openxmlformats.org/drawingml/2006/main" xmlns:r="http://schemas.openxmlformats.org/officeDocument/2006/relationships" xmlns:p="http://schemas.openxmlformats.org/presentationml/2006/main">
+  <p:cSld>
+    <p:spTree>
+      <p:nvGrpSpPr>
+        <p:cNvPr id="1" name=""/>
+        <p:cNvGrpSpPr/>
+        <p:nvPr/>
+      </p:nvGrpSpPr>
+      <p:grpSpPr>
+        <a:xfrm>
+          <a:off x="0" y="0"/>
+          <a:ext cx="0" cy="0"/>
+          <a:chOff x="0" y="0"/>
+          <a:chExt cx="0" cy="0"/>
+        </a:xfrm>
+      </p:grpSpPr>
+      <p:sp>
+        <p:nvSpPr>
+          <p:cNvPr id="2" name="Slide Image Placeholder 1"/>
+          <p:cNvSpPr>
+            <a:spLocks noGrp="1" noRot="1" noChangeAspect="1"/>
+          </p:cNvSpPr>
+          <p:nvPr>
+            <p:ph type="sldImg"/>
+          </p:nvPr>
+        </p:nvSpPr>
+        <p:spPr/>
+      </p:sp>
+      <p:sp>
+        <p:nvSpPr>
+          <p:cNvPr id="3" name="Notes Placeholder 2"/>
+          <p:cNvSpPr>
+            <a:spLocks noGrp="1"/>
+          </p:cNvSpPr>
+          <p:nvPr>
+            <p:ph type="body" idx="1"/>
+          </p:nvPr>
+        </p:nvSpPr>
+        <p:spPr/>
+        <p:txBody>
+          <a:bodyPr/>
+          <a:lstStyle/>
+          <a:p>
+            <a:r>
+              <a:rPr lang="en-US" dirty="0"/>
+              <a:t/>
+            </a:r>
+            <a:endParaRPr lang="en-US" dirty="0"/>
+          </a:p>
+        </p:txBody>
+      </p:sp>
+      <p:sp>
+        <p:nvSpPr>
+          <p:cNvPr id="4" name="Slide Number Placeholder 3"/>
+          <p:cNvSpPr>
+            <a:spLocks noGrp="1"/>
+          </p:cNvSpPr>
+          <p:nvPr>
+            <p:ph type="sldNum" sz="quarter" idx="10"/>
+          </p:nvPr>
+        </p:nvSpPr>
+        <p:spPr/>
+        <p:txBody>
+          <a:bodyPr/>
+          <a:lstStyle/>
+          <a:p>
+            <a:fld id="{F7021451-1387-4CA6-816F-3879F97B5CBC}" type="slidenum">
+              <a:rPr lang="en-US"/>
+              <a:t>7</a:t>
+            </a:fld>
+            <a:endParaRPr lang="en-US"/>
+          </a:p>
+        </p:txBody>
+      </p:sp>
+    </p:spTree>
+    <p:extLst>
+      <p:ext uri="{BB962C8B-B14F-4D97-AF65-F5344CB8AC3E}">
+        <p14:creationId xmlns:p14="http://schemas.microsoft.com/office/powerpoint/2010/main" val="1024086991"/>
+      </p:ext>
+    </p:extLst>
+  </p:cSld>
+  <p:clrMapOvr>
+    <a:masterClrMapping/>
+  </p:clrMapOvr>
+</p:notes>
+</file>
+
+<file path=ppt/notesSlides/notesSlide8.xml><?xml version="1.0" encoding="utf-8"?>
+<p:notes xmlns:a="http://schemas.openxmlformats.org/drawingml/2006/main" xmlns:r="http://schemas.openxmlformats.org/officeDocument/2006/relationships" xmlns:p="http://schemas.openxmlformats.org/presentationml/2006/main">
+  <p:cSld>
+    <p:spTree>
+      <p:nvGrpSpPr>
+        <p:cNvPr id="1" name=""/>
+        <p:cNvGrpSpPr/>
+        <p:nvPr/>
+      </p:nvGrpSpPr>
+      <p:grpSpPr>
+        <a:xfrm>
+          <a:off x="0" y="0"/>
+          <a:ext cx="0" cy="0"/>
+          <a:chOff x="0" y="0"/>
+          <a:chExt cx="0" cy="0"/>
+        </a:xfrm>
+      </p:grpSpPr>
+      <p:sp>
+        <p:nvSpPr>
+          <p:cNvPr id="2" name="Slide Image Placeholder 1"/>
+          <p:cNvSpPr>
+            <a:spLocks noGrp="1" noRot="1" noChangeAspect="1"/>
+          </p:cNvSpPr>
+          <p:nvPr>
+            <p:ph type="sldImg"/>
+          </p:nvPr>
+        </p:nvSpPr>
+        <p:spPr/>
+      </p:sp>
+      <p:sp>
+        <p:nvSpPr>
+          <p:cNvPr id="3" name="Notes Placeholder 2"/>
+          <p:cNvSpPr>
+            <a:spLocks noGrp="1"/>
+          </p:cNvSpPr>
+          <p:nvPr>
+            <p:ph type="body" idx="1"/>
+          </p:nvPr>
+        </p:nvSpPr>
+        <p:spPr/>
+        <p:txBody>
+          <a:bodyPr/>
+          <a:lstStyle/>
+          <a:p>
+            <a:r>
+              <a:rPr lang="en-US" dirty="0"/>
+              <a:t/>
+            </a:r>
+            <a:endParaRPr lang="en-US" dirty="0"/>
+          </a:p>
+        </p:txBody>
+      </p:sp>
+      <p:sp>
+        <p:nvSpPr>
+          <p:cNvPr id="4" name="Slide Number Placeholder 3"/>
+          <p:cNvSpPr>
+            <a:spLocks noGrp="1"/>
+          </p:cNvSpPr>
+          <p:nvPr>
+            <p:ph type="sldNum" sz="quarter" idx="10"/>
+          </p:nvPr>
+        </p:nvSpPr>
+        <p:spPr/>
+        <p:txBody>
+          <a:bodyPr/>
+          <a:lstStyle/>
+          <a:p>
+            <a:fld id="{F7021451-1387-4CA6-816F-3879F97B5CBC}" type="slidenum">
+              <a:rPr lang="en-US"/>
+              <a:t>8</a:t>
             </a:fld>
             <a:endParaRPr lang="en-US"/>
           </a:p>
@@ -1210,13 +1477,6 @@
 <file path=ppt/slides/slide1.xml><?xml version="1.0" encoding="utf-8"?>
 <p:sld xmlns:a="http://schemas.openxmlformats.org/drawingml/2006/main" xmlns:r="http://schemas.openxmlformats.org/officeDocument/2006/relationships" xmlns:p="http://schemas.openxmlformats.org/presentationml/2006/main">
   <p:cSld name="Slide 1">
-    <p:bg>
-      <p:bgPr>
-        <a:solidFill>
-          <a:srgbClr val="1B2A4A"/>
-        </a:solidFill>
-      </p:bgPr>
-    </p:bg>
     <p:spTree>
       <p:nvGrpSpPr>
         <p:cNvPr id="1" name=""/>
@@ -1240,7 +1500,27 @@
         <p:spPr>
           <a:xfrm>
             <a:off x="0" y="0"/>
-            <a:ext cx="109728" cy="5143500"/>
+            <a:ext cx="9144000" cy="5143500"/>
+          </a:xfrm>
+          <a:prstGeom prst="rect">
+            <a:avLst/>
+          </a:prstGeom>
+          <a:solidFill>
+            <a:srgbClr val="1B2A4A"/>
+          </a:solidFill>
+          <a:ln/>
+        </p:spPr>
+      </p:sp>
+      <p:sp>
+        <p:nvSpPr>
+          <p:cNvPr id="3" name="Shape 1"/>
+          <p:cNvSpPr/>
+          <p:nvPr/>
+        </p:nvSpPr>
+        <p:spPr>
+          <a:xfrm>
+            <a:off x="0" y="4777740"/>
+            <a:ext cx="9144000" cy="365760"/>
           </a:xfrm>
           <a:prstGeom prst="rect">
             <a:avLst/>
@@ -1253,14 +1533,14 @@
       </p:sp>
       <p:sp>
         <p:nvSpPr>
-          <p:cNvPr id="3" name="Text 1"/>
+          <p:cNvPr id="4" name="Text 2"/>
           <p:cNvSpPr/>
           <p:nvPr/>
         </p:nvSpPr>
         <p:spPr>
           <a:xfrm>
             <a:off x="731520" y="1097280"/>
-            <a:ext cx="7772400" cy="1371600"/>
+            <a:ext cx="7680960" cy="457200"/>
           </a:xfrm>
           <a:prstGeom prst="rect">
             <a:avLst/>
@@ -1270,6 +1550,45 @@
         </p:spPr>
         <p:txBody>
           <a:bodyPr wrap="square" rtlCol="0" anchor="ctr"/>
+          <a:lstStyle/>
+          <a:p>
+            <a:pPr indent="0" marL="0">
+              <a:buNone/>
+            </a:pPr>
+            <a:r>
+              <a:rPr lang="en-US" sz="1400" b="1" spc="400" kern="0" dirty="0">
+                <a:solidFill>
+                  <a:srgbClr val="2A9D8F"/>
+                </a:solidFill>
+                <a:latin typeface="Calibri" pitchFamily="34" charset="0"/>
+                <a:ea typeface="Calibri" pitchFamily="34" charset="-122"/>
+                <a:cs typeface="Calibri" pitchFamily="34" charset="-120"/>
+              </a:rPr>
+              <a:t>GRADE 6 MATHEMATICS</a:t>
+            </a:r>
+            <a:endParaRPr lang="en-US" sz="1400" dirty="0"/>
+          </a:p>
+        </p:txBody>
+      </p:sp>
+      <p:sp>
+        <p:nvSpPr>
+          <p:cNvPr id="5" name="Text 3"/>
+          <p:cNvSpPr/>
+          <p:nvPr/>
+        </p:nvSpPr>
+        <p:spPr>
+          <a:xfrm>
+            <a:off x="731520" y="1645920"/>
+            <a:ext cx="7680960" cy="1463040"/>
+          </a:xfrm>
+          <a:prstGeom prst="rect">
+            <a:avLst/>
+          </a:prstGeom>
+          <a:noFill/>
+          <a:ln/>
+        </p:spPr>
+        <p:txBody>
+          <a:bodyPr wrap="square" rtlCol="0" anchor="t"/>
           <a:lstStyle/>
           <a:p>
             <a:pPr indent="0" marL="0">
@@ -1292,14 +1611,14 @@
       </p:sp>
       <p:sp>
         <p:nvSpPr>
-          <p:cNvPr id="4" name="Text 2"/>
-          <p:cNvSpPr/>
-          <p:nvPr/>
-        </p:nvSpPr>
-        <p:spPr>
-          <a:xfrm>
-            <a:off x="731520" y="2560320"/>
-            <a:ext cx="7772400" cy="548640"/>
+          <p:cNvPr id="6" name="Text 4"/>
+          <p:cNvSpPr/>
+          <p:nvPr/>
+        </p:nvSpPr>
+        <p:spPr>
+          <a:xfrm>
+            <a:off x="731520" y="3200400"/>
+            <a:ext cx="7680960" cy="548640"/>
           </a:xfrm>
           <a:prstGeom prst="rect">
             <a:avLst/>
@@ -1315,15 +1634,15 @@
               <a:buNone/>
             </a:pPr>
             <a:r>
-              <a:rPr lang="en-US" sz="1600" dirty="0">
+              <a:rPr lang="en-US" sz="1600" i="1" dirty="0">
                 <a:solidFill>
-                  <a:srgbClr val="E9C46A"/>
+                  <a:srgbClr val="9B9690"/>
                 </a:solidFill>
                 <a:latin typeface="Calibri" pitchFamily="34" charset="0"/>
                 <a:ea typeface="Calibri" pitchFamily="34" charset="-122"/>
                 <a:cs typeface="Calibri" pitchFamily="34" charset="-120"/>
               </a:rPr>
-              <a:t>Grade 6 Mathematics · Mr Zocchi</a:t>
+              <a:t>How much a container can hold</a:t>
             </a:r>
             <a:endParaRPr lang="en-US" sz="1600" dirty="0"/>
           </a:p>
@@ -1331,36 +1650,14 @@
       </p:sp>
       <p:sp>
         <p:nvSpPr>
-          <p:cNvPr id="5" name="Shape 3"/>
-          <p:cNvSpPr/>
-          <p:nvPr/>
-        </p:nvSpPr>
-        <p:spPr>
-          <a:xfrm>
-            <a:off x="731520" y="3474720"/>
-            <a:ext cx="2011680" cy="411480"/>
-          </a:xfrm>
-          <a:prstGeom prst="roundRect">
-            <a:avLst>
-              <a:gd name="adj" fmla="val 17778"/>
-            </a:avLst>
-          </a:prstGeom>
-          <a:solidFill>
-            <a:srgbClr val="2A9D8F"/>
-          </a:solidFill>
-          <a:ln/>
-        </p:spPr>
-      </p:sp>
-      <p:sp>
-        <p:nvSpPr>
-          <p:cNvPr id="6" name="Text 4"/>
-          <p:cNvSpPr/>
-          <p:nvPr/>
-        </p:nvSpPr>
-        <p:spPr>
-          <a:xfrm>
-            <a:off x="731520" y="3474720"/>
-            <a:ext cx="2011680" cy="411480"/>
+          <p:cNvPr id="7" name="Text 5"/>
+          <p:cNvSpPr/>
+          <p:nvPr/>
+        </p:nvSpPr>
+        <p:spPr>
+          <a:xfrm>
+            <a:off x="731520" y="4206240"/>
+            <a:ext cx="3657600" cy="365760"/>
           </a:xfrm>
           <a:prstGeom prst="rect">
             <a:avLst/>
@@ -1372,19 +1669,19 @@
           <a:bodyPr wrap="square" rtlCol="0" anchor="ctr"/>
           <a:lstStyle/>
           <a:p>
-            <a:pPr algn="ctr" indent="0" marL="0">
+            <a:pPr indent="0" marL="0">
               <a:buNone/>
             </a:pPr>
             <a:r>
-              <a:rPr lang="en-US" sz="1200" b="1" dirty="0">
+              <a:rPr lang="en-US" sz="1200" dirty="0">
                 <a:solidFill>
-                  <a:srgbClr val="FFFFFF"/>
+                  <a:srgbClr val="6B6660"/>
                 </a:solidFill>
                 <a:latin typeface="Calibri" pitchFamily="34" charset="0"/>
                 <a:ea typeface="Calibri" pitchFamily="34" charset="-122"/>
                 <a:cs typeface="Calibri" pitchFamily="34" charset="-120"/>
               </a:rPr>
-              <a:t>Term 3 · Geometry</a:t>
+              <a:t>Mr Zocchi</a:t>
             </a:r>
             <a:endParaRPr lang="en-US" sz="1200" dirty="0"/>
           </a:p>
@@ -1401,13 +1698,6 @@
 <file path=ppt/slides/slide2.xml><?xml version="1.0" encoding="utf-8"?>
 <p:sld xmlns:a="http://schemas.openxmlformats.org/drawingml/2006/main" xmlns:r="http://schemas.openxmlformats.org/officeDocument/2006/relationships" xmlns:p="http://schemas.openxmlformats.org/presentationml/2006/main">
   <p:cSld name="Slide 2">
-    <p:bg>
-      <p:bgPr>
-        <a:solidFill>
-          <a:srgbClr val="FAF8F5"/>
-        </a:solidFill>
-      </p:bgPr>
-    </p:bg>
     <p:spTree>
       <p:nvGrpSpPr>
         <p:cNvPr id="1" name=""/>
@@ -1431,13 +1721,13 @@
         <p:spPr>
           <a:xfrm>
             <a:off x="0" y="0"/>
-            <a:ext cx="9144000" cy="54864"/>
+            <a:ext cx="9144000" cy="5143500"/>
           </a:xfrm>
           <a:prstGeom prst="rect">
             <a:avLst/>
           </a:prstGeom>
           <a:solidFill>
-            <a:srgbClr val="2A9D8F"/>
+            <a:srgbClr val="111D35"/>
           </a:solidFill>
           <a:ln/>
         </p:spPr>
@@ -1450,8 +1740,8 @@
         </p:nvSpPr>
         <p:spPr>
           <a:xfrm>
-            <a:off x="7772400" y="4709160"/>
-            <a:ext cx="1097280" cy="320040"/>
+            <a:off x="6858000" y="182880"/>
+            <a:ext cx="2286000" cy="2743200"/>
           </a:xfrm>
           <a:prstGeom prst="rect">
             <a:avLst/>
@@ -1463,86 +1753,75 @@
           <a:bodyPr wrap="square" rtlCol="0" anchor="ctr"/>
           <a:lstStyle/>
           <a:p>
-            <a:pPr algn="r" indent="0" marL="0">
+            <a:pPr algn="ctr" indent="0" marL="0">
               <a:buNone/>
             </a:pPr>
             <a:r>
-              <a:rPr lang="en-US" sz="900" dirty="0">
+              <a:rPr lang="en-US" sz="16000" b="1" dirty="0">
                 <a:solidFill>
-                  <a:srgbClr val="6B6660"/>
+                  <a:srgbClr val="2A9D8F">
+                    <a:alpha val="80000"/>
+                  </a:srgbClr>
+                </a:solidFill>
+                <a:latin typeface="Georgia" pitchFamily="34" charset="0"/>
+                <a:ea typeface="Georgia" pitchFamily="34" charset="-122"/>
+                <a:cs typeface="Georgia" pitchFamily="34" charset="-120"/>
+              </a:rPr>
+              <a:t>?</a:t>
+            </a:r>
+            <a:endParaRPr lang="en-US" sz="16000" dirty="0"/>
+          </a:p>
+        </p:txBody>
+      </p:sp>
+      <p:sp>
+        <p:nvSpPr>
+          <p:cNvPr id="4" name="Text 2"/>
+          <p:cNvSpPr/>
+          <p:nvPr/>
+        </p:nvSpPr>
+        <p:spPr>
+          <a:xfrm>
+            <a:off x="731520" y="548640"/>
+            <a:ext cx="2743200" cy="365760"/>
+          </a:xfrm>
+          <a:prstGeom prst="rect">
+            <a:avLst/>
+          </a:prstGeom>
+          <a:noFill/>
+          <a:ln/>
+        </p:spPr>
+        <p:txBody>
+          <a:bodyPr wrap="square" rtlCol="0" anchor="ctr"/>
+          <a:lstStyle/>
+          <a:p>
+            <a:pPr indent="0" marL="0">
+              <a:buNone/>
+            </a:pPr>
+            <a:r>
+              <a:rPr lang="en-US" sz="1200" b="1" spc="400" kern="0" dirty="0">
+                <a:solidFill>
+                  <a:srgbClr val="2A9D8F"/>
                 </a:solidFill>
                 <a:latin typeface="Calibri" pitchFamily="34" charset="0"/>
                 <a:ea typeface="Calibri" pitchFamily="34" charset="-122"/>
                 <a:cs typeface="Calibri" pitchFamily="34" charset="-120"/>
               </a:rPr>
-              <a:t>2 / 5</a:t>
-            </a:r>
-            <a:endParaRPr lang="en-US" sz="900" dirty="0"/>
-          </a:p>
-        </p:txBody>
-      </p:sp>
-      <p:sp>
-        <p:nvSpPr>
-          <p:cNvPr id="4" name="Shape 2"/>
-          <p:cNvSpPr/>
-          <p:nvPr/>
-        </p:nvSpPr>
-        <p:spPr>
-          <a:xfrm>
-            <a:off x="1371600" y="914400"/>
-            <a:ext cx="6400800" cy="3200400"/>
-          </a:xfrm>
-          <a:prstGeom prst="rect">
-            <a:avLst/>
-          </a:prstGeom>
-          <a:solidFill>
-            <a:srgbClr val="FFFFFF"/>
-          </a:solidFill>
-          <a:ln w="12700">
-            <a:solidFill>
-              <a:srgbClr val="E5E2DC"/>
-            </a:solidFill>
-            <a:prstDash val="solid"/>
-          </a:ln>
-          <a:effectLst>
-            <a:outerShdw sx="100000" sy="100000" kx="0" ky="0" algn="bl" rotWithShape="0" blurRad="50800" dist="25400" dir="8100000">
-              <a:srgbClr val="000000">
-                <a:alpha val="10000"/>
-              </a:srgbClr>
-            </a:outerShdw>
-          </a:effectLst>
-        </p:spPr>
-      </p:sp>
-      <p:sp>
-        <p:nvSpPr>
-          <p:cNvPr id="5" name="Shape 3"/>
-          <p:cNvSpPr/>
-          <p:nvPr/>
-        </p:nvSpPr>
-        <p:spPr>
-          <a:xfrm>
-            <a:off x="1371600" y="914400"/>
-            <a:ext cx="91440" cy="3200400"/>
-          </a:xfrm>
-          <a:prstGeom prst="rect">
-            <a:avLst/>
-          </a:prstGeom>
-          <a:solidFill>
-            <a:srgbClr val="2A9D8F"/>
-          </a:solidFill>
-          <a:ln/>
-        </p:spPr>
-      </p:sp>
-      <p:sp>
-        <p:nvSpPr>
-          <p:cNvPr id="6" name="Text 4"/>
-          <p:cNvSpPr/>
-          <p:nvPr/>
-        </p:nvSpPr>
-        <p:spPr>
-          <a:xfrm>
-            <a:off x="1828800" y="1097280"/>
-            <a:ext cx="5669280" cy="640080"/>
+              <a:t>INQUIRY</a:t>
+            </a:r>
+            <a:endParaRPr lang="en-US" sz="1200" dirty="0"/>
+          </a:p>
+        </p:txBody>
+      </p:sp>
+      <p:sp>
+        <p:nvSpPr>
+          <p:cNvPr id="5" name="Text 3"/>
+          <p:cNvSpPr/>
+          <p:nvPr/>
+        </p:nvSpPr>
+        <p:spPr>
+          <a:xfrm>
+            <a:off x="731520" y="1005840"/>
+            <a:ext cx="6858000" cy="1463040"/>
           </a:xfrm>
           <a:prstGeom prst="rect">
             <a:avLst/>
@@ -1551,37 +1830,37 @@
           <a:ln/>
         </p:spPr>
         <p:txBody>
-          <a:bodyPr wrap="square" rtlCol="0" anchor="ctr"/>
+          <a:bodyPr wrap="square" rtlCol="0" anchor="t"/>
           <a:lstStyle/>
           <a:p>
             <a:pPr indent="0" marL="0">
               <a:buNone/>
             </a:pPr>
             <a:r>
-              <a:rPr lang="en-US" sz="2400" b="1" dirty="0">
+              <a:rPr lang="en-US" sz="2800" b="1" dirty="0">
                 <a:solidFill>
-                  <a:srgbClr val="1B2A4A"/>
+                  <a:srgbClr val="FFFFFF"/>
                 </a:solidFill>
                 <a:latin typeface="Georgia" pitchFamily="34" charset="0"/>
                 <a:ea typeface="Georgia" pitchFamily="34" charset="-122"/>
                 <a:cs typeface="Georgia" pitchFamily="34" charset="-120"/>
               </a:rPr>
-              <a:t>Volume and Capacity</a:t>
-            </a:r>
-            <a:endParaRPr lang="en-US" sz="2400" dirty="0"/>
-          </a:p>
-        </p:txBody>
-      </p:sp>
-      <p:sp>
-        <p:nvSpPr>
-          <p:cNvPr id="7" name="Text 5"/>
-          <p:cNvSpPr/>
-          <p:nvPr/>
-        </p:nvSpPr>
-        <p:spPr>
-          <a:xfrm>
-            <a:off x="1828800" y="1828800"/>
-            <a:ext cx="5669280" cy="2011680"/>
+              <a:t>A Korean soju bottle holds 360 mL. A German beer Maß holds 1,000 mL. How many soju bottles fit in one Maß?</a:t>
+            </a:r>
+            <a:endParaRPr lang="en-US" sz="2800" dirty="0"/>
+          </a:p>
+        </p:txBody>
+      </p:sp>
+      <p:sp>
+        <p:nvSpPr>
+          <p:cNvPr id="6" name="Text 4"/>
+          <p:cNvSpPr/>
+          <p:nvPr/>
+        </p:nvSpPr>
+        <p:spPr>
+          <a:xfrm>
+            <a:off x="731520" y="2560320"/>
+            <a:ext cx="6858000" cy="548640"/>
           </a:xfrm>
           <a:prstGeom prst="rect">
             <a:avLst/>
@@ -1590,27 +1869,168 @@
           <a:ln/>
         </p:spPr>
         <p:txBody>
-          <a:bodyPr wrap="square" rtlCol="0" anchor="t"/>
+          <a:bodyPr wrap="square" rtlCol="0" anchor="ctr"/>
           <a:lstStyle/>
           <a:p>
             <a:pPr indent="0" marL="0">
-              <a:lnSpc>
-                <a:spcPct val="130000"/>
-              </a:lnSpc>
               <a:buNone/>
             </a:pPr>
             <a:r>
-              <a:rPr lang="en-US" sz="1500" dirty="0">
+              <a:rPr lang="en-US" sz="1400" i="1" dirty="0">
                 <a:solidFill>
-                  <a:srgbClr val="3D3A36"/>
+                  <a:srgbClr val="9B9690"/>
                 </a:solidFill>
                 <a:latin typeface="Calibri" pitchFamily="34" charset="0"/>
                 <a:ea typeface="Calibri" pitchFamily="34" charset="-122"/>
                 <a:cs typeface="Calibri" pitchFamily="34" charset="-120"/>
               </a:rPr>
-              <a:t>Capacity is the maximum amount a container can hold, usually measured in litres (L) and millilitres (mL). Volume and capacity are closely linked: 1 cm³ of space holds exactly 1 mL of water. Understanding this connection is essential for real-world problems.</a:t>
-            </a:r>
-            <a:endParaRPr lang="en-US" sz="1500" dirty="0"/>
+              <a:t>Capacity measures how much liquid a container can hold.</a:t>
+            </a:r>
+            <a:endParaRPr lang="en-US" sz="1400" dirty="0"/>
+          </a:p>
+        </p:txBody>
+      </p:sp>
+      <p:sp>
+        <p:nvSpPr>
+          <p:cNvPr id="7" name="Shape 5"/>
+          <p:cNvSpPr/>
+          <p:nvPr/>
+        </p:nvSpPr>
+        <p:spPr>
+          <a:xfrm>
+            <a:off x="548640" y="3200400"/>
+            <a:ext cx="7315200" cy="1645920"/>
+          </a:xfrm>
+          <a:prstGeom prst="rect">
+            <a:avLst/>
+          </a:prstGeom>
+          <a:solidFill>
+            <a:srgbClr val="243660"/>
+          </a:solidFill>
+          <a:ln/>
+        </p:spPr>
+      </p:sp>
+      <p:sp>
+        <p:nvSpPr>
+          <p:cNvPr id="8" name="Text 6"/>
+          <p:cNvSpPr/>
+          <p:nvPr/>
+        </p:nvSpPr>
+        <p:spPr>
+          <a:xfrm>
+            <a:off x="731520" y="3246120"/>
+            <a:ext cx="3657600" cy="320040"/>
+          </a:xfrm>
+          <a:prstGeom prst="rect">
+            <a:avLst/>
+          </a:prstGeom>
+          <a:noFill/>
+          <a:ln/>
+        </p:spPr>
+        <p:txBody>
+          <a:bodyPr wrap="square" rtlCol="0" anchor="ctr"/>
+          <a:lstStyle/>
+          <a:p>
+            <a:pPr indent="0" marL="0">
+              <a:buNone/>
+            </a:pPr>
+            <a:r>
+              <a:rPr lang="en-US" sz="1100" b="1" spc="200" kern="0" dirty="0">
+                <a:solidFill>
+                  <a:srgbClr val="2A9D8F"/>
+                </a:solidFill>
+                <a:latin typeface="Calibri" pitchFamily="34" charset="0"/>
+                <a:ea typeface="Calibri" pitchFamily="34" charset="-122"/>
+                <a:cs typeface="Calibri" pitchFamily="34" charset="-120"/>
+              </a:rPr>
+              <a:t>Think — Pair — Share</a:t>
+            </a:r>
+            <a:endParaRPr lang="en-US" sz="1100" dirty="0"/>
+          </a:p>
+        </p:txBody>
+      </p:sp>
+      <p:sp>
+        <p:nvSpPr>
+          <p:cNvPr id="9" name="Text 7"/>
+          <p:cNvSpPr/>
+          <p:nvPr/>
+        </p:nvSpPr>
+        <p:spPr>
+          <a:xfrm>
+            <a:off x="731520" y="3566160"/>
+            <a:ext cx="6949440" cy="1188720"/>
+          </a:xfrm>
+          <a:prstGeom prst="rect">
+            <a:avLst/>
+          </a:prstGeom>
+          <a:noFill/>
+          <a:ln/>
+        </p:spPr>
+        <p:txBody>
+          <a:bodyPr wrap="square" rtlCol="0" anchor="ctr"/>
+          <a:lstStyle/>
+          <a:p>
+            <a:pPr marL="342900" indent="-342900">
+              <a:spcAft>
+                <a:spcPts val="600"/>
+              </a:spcAft>
+              <a:buSzPct val="100000"/>
+              <a:buChar char="•"/>
+            </a:pPr>
+            <a:r>
+              <a:rPr lang="en-US" sz="1400" dirty="0">
+                <a:solidFill>
+                  <a:srgbClr val="E5E2DC"/>
+                </a:solidFill>
+                <a:latin typeface="Calibri" pitchFamily="34" charset="0"/>
+                <a:ea typeface="Calibri" pitchFamily="34" charset="-122"/>
+                <a:cs typeface="Calibri" pitchFamily="34" charset="-120"/>
+              </a:rPr>
+              <a:t>What's the difference between volume and capacity?</a:t>
+            </a:r>
+            <a:endParaRPr lang="en-US" sz="1400" dirty="0"/>
+          </a:p>
+          <a:p>
+            <a:pPr marL="342900" indent="-342900">
+              <a:spcAft>
+                <a:spcPts val="600"/>
+              </a:spcAft>
+              <a:buSzPct val="100000"/>
+              <a:buChar char="•"/>
+            </a:pPr>
+            <a:r>
+              <a:rPr lang="en-US" sz="1400" dirty="0">
+                <a:solidFill>
+                  <a:srgbClr val="E5E2DC"/>
+                </a:solidFill>
+                <a:latin typeface="Calibri" pitchFamily="34" charset="0"/>
+                <a:ea typeface="Calibri" pitchFamily="34" charset="-122"/>
+                <a:cs typeface="Calibri" pitchFamily="34" charset="-120"/>
+              </a:rPr>
+              <a:t>What units do we use for liquids?</a:t>
+            </a:r>
+            <a:endParaRPr lang="en-US" sz="1400" dirty="0"/>
+          </a:p>
+          <a:p>
+            <a:pPr marL="342900" indent="-342900">
+              <a:spcAft>
+                <a:spcPts val="600"/>
+              </a:spcAft>
+              <a:buSzPct val="100000"/>
+              <a:buChar char="•"/>
+            </a:pPr>
+            <a:r>
+              <a:rPr lang="en-US" sz="1400" dirty="0">
+                <a:solidFill>
+                  <a:srgbClr val="E5E2DC"/>
+                </a:solidFill>
+                <a:latin typeface="Calibri" pitchFamily="34" charset="0"/>
+                <a:ea typeface="Calibri" pitchFamily="34" charset="-122"/>
+                <a:cs typeface="Calibri" pitchFamily="34" charset="-120"/>
+              </a:rPr>
+              <a:t>How do cm³ and mL connect?</a:t>
+            </a:r>
+            <a:endParaRPr lang="en-US" sz="1400" dirty="0"/>
           </a:p>
         </p:txBody>
       </p:sp>
@@ -1655,7 +2075,27 @@
         <p:spPr>
           <a:xfrm>
             <a:off x="0" y="0"/>
-            <a:ext cx="9144000" cy="54864"/>
+            <a:ext cx="9144000" cy="822960"/>
+          </a:xfrm>
+          <a:prstGeom prst="rect">
+            <a:avLst/>
+          </a:prstGeom>
+          <a:solidFill>
+            <a:srgbClr val="FFFFFF"/>
+          </a:solidFill>
+          <a:ln/>
+        </p:spPr>
+      </p:sp>
+      <p:sp>
+        <p:nvSpPr>
+          <p:cNvPr id="3" name="Shape 1"/>
+          <p:cNvSpPr/>
+          <p:nvPr/>
+        </p:nvSpPr>
+        <p:spPr>
+          <a:xfrm>
+            <a:off x="0" y="795528"/>
+            <a:ext cx="9144000" cy="27432"/>
           </a:xfrm>
           <a:prstGeom prst="rect">
             <a:avLst/>
@@ -1668,14 +2108,14 @@
       </p:sp>
       <p:sp>
         <p:nvSpPr>
-          <p:cNvPr id="3" name="Text 1"/>
-          <p:cNvSpPr/>
-          <p:nvPr/>
-        </p:nvSpPr>
-        <p:spPr>
-          <a:xfrm>
-            <a:off x="7772400" y="4709160"/>
-            <a:ext cx="1097280" cy="320040"/>
+          <p:cNvPr id="4" name="Text 2"/>
+          <p:cNvSpPr/>
+          <p:nvPr/>
+        </p:nvSpPr>
+        <p:spPr>
+          <a:xfrm>
+            <a:off x="640080" y="91440"/>
+            <a:ext cx="7863840" cy="640080"/>
           </a:xfrm>
           <a:prstGeom prst="rect">
             <a:avLst/>
@@ -1684,53 +2124,14 @@
           <a:ln/>
         </p:spPr>
         <p:txBody>
-          <a:bodyPr wrap="square" rtlCol="0" anchor="ctr"/>
-          <a:lstStyle/>
-          <a:p>
-            <a:pPr algn="r" indent="0" marL="0">
-              <a:buNone/>
-            </a:pPr>
-            <a:r>
-              <a:rPr lang="en-US" sz="900" dirty="0">
-                <a:solidFill>
-                  <a:srgbClr val="6B6660"/>
-                </a:solidFill>
-                <a:latin typeface="Calibri" pitchFamily="34" charset="0"/>
-                <a:ea typeface="Calibri" pitchFamily="34" charset="-122"/>
-                <a:cs typeface="Calibri" pitchFamily="34" charset="-120"/>
-              </a:rPr>
-              <a:t>3 / 5</a:t>
-            </a:r>
-            <a:endParaRPr lang="en-US" sz="900" dirty="0"/>
-          </a:p>
-        </p:txBody>
-      </p:sp>
-      <p:sp>
-        <p:nvSpPr>
-          <p:cNvPr id="4" name="Text 2"/>
-          <p:cNvSpPr/>
-          <p:nvPr/>
-        </p:nvSpPr>
-        <p:spPr>
-          <a:xfrm>
-            <a:off x="457200" y="274320"/>
-            <a:ext cx="8229600" cy="640080"/>
-          </a:xfrm>
-          <a:prstGeom prst="rect">
-            <a:avLst/>
-          </a:prstGeom>
-          <a:noFill/>
-          <a:ln/>
-        </p:spPr>
-        <p:txBody>
-          <a:bodyPr wrap="square" rtlCol="0" anchor="ctr"/>
+          <a:bodyPr wrap="square" lIns="0" tIns="0" rIns="0" bIns="0" rtlCol="0" anchor="ctr"/>
           <a:lstStyle/>
           <a:p>
             <a:pPr indent="0" marL="0">
               <a:buNone/>
             </a:pPr>
             <a:r>
-              <a:rPr lang="en-US" sz="2600" b="1" dirty="0">
+              <a:rPr lang="en-US" sz="2200" b="1" dirty="0">
                 <a:solidFill>
                   <a:srgbClr val="1B2A4A"/>
                 </a:solidFill>
@@ -1738,9 +2139,9 @@
                 <a:ea typeface="Georgia" pitchFamily="34" charset="-122"/>
                 <a:cs typeface="Georgia" pitchFamily="34" charset="-120"/>
               </a:rPr>
-              <a:t>Key Conversions</a:t>
-            </a:r>
-            <a:endParaRPr lang="en-US" sz="2600" dirty="0"/>
+              <a:t>Volume vs. Capacity</a:t>
+            </a:r>
+            <a:endParaRPr lang="en-US" sz="2200" dirty="0"/>
           </a:p>
         </p:txBody>
       </p:sp>
@@ -1752,8 +2153,8 @@
         </p:nvSpPr>
         <p:spPr>
           <a:xfrm>
-            <a:off x="457200" y="1188720"/>
-            <a:ext cx="3840480" cy="3474720"/>
+            <a:off x="640080" y="1005840"/>
+            <a:ext cx="7863840" cy="2926080"/>
           </a:xfrm>
           <a:prstGeom prst="rect">
             <a:avLst/>
@@ -1762,18 +2163,18 @@
           <a:ln/>
         </p:spPr>
         <p:txBody>
-          <a:bodyPr wrap="square" rtlCol="0" anchor="t"/>
+          <a:bodyPr wrap="square" rtlCol="0" anchor="ctr"/>
           <a:lstStyle/>
           <a:p>
             <a:pPr marL="342900" indent="-342900">
               <a:spcAft>
-                <a:spcPts val="600"/>
+                <a:spcPts val="800"/>
               </a:spcAft>
               <a:buSzPct val="100000"/>
               <a:buChar char="•"/>
             </a:pPr>
             <a:r>
-              <a:rPr lang="en-US" sz="1400" dirty="0">
+              <a:rPr lang="en-US" sz="1600" dirty="0">
                 <a:solidFill>
                   <a:srgbClr val="3D3A36"/>
                 </a:solidFill>
@@ -1781,20 +2182,20 @@
                 <a:ea typeface="Calibri" pitchFamily="34" charset="-122"/>
                 <a:cs typeface="Calibri" pitchFamily="34" charset="-120"/>
               </a:rPr>
-              <a:t>1 mL = 1 cm³</a:t>
-            </a:r>
-            <a:endParaRPr lang="en-US" sz="1400" dirty="0"/>
+              <a:t>Volume = how much 3D space (cm³, m³).</a:t>
+            </a:r>
+            <a:endParaRPr lang="en-US" sz="1600" dirty="0"/>
           </a:p>
           <a:p>
             <a:pPr marL="342900" indent="-342900">
               <a:spcAft>
-                <a:spcPts val="600"/>
+                <a:spcPts val="800"/>
               </a:spcAft>
               <a:buSzPct val="100000"/>
               <a:buChar char="•"/>
             </a:pPr>
             <a:r>
-              <a:rPr lang="en-US" sz="1400" dirty="0">
+              <a:rPr lang="en-US" sz="1600" dirty="0">
                 <a:solidFill>
                   <a:srgbClr val="3D3A36"/>
                 </a:solidFill>
@@ -1802,20 +2203,20 @@
                 <a:ea typeface="Calibri" pitchFamily="34" charset="-122"/>
                 <a:cs typeface="Calibri" pitchFamily="34" charset="-120"/>
               </a:rPr>
-              <a:t>1 L = 1000 mL = 1000 cm³</a:t>
-            </a:r>
-            <a:endParaRPr lang="en-US" sz="1400" dirty="0"/>
+              <a:t>Capacity = how much liquid a container holds (mL, L).</a:t>
+            </a:r>
+            <a:endParaRPr lang="en-US" sz="1600" dirty="0"/>
           </a:p>
           <a:p>
             <a:pPr marL="342900" indent="-342900">
               <a:spcAft>
-                <a:spcPts val="600"/>
+                <a:spcPts val="800"/>
               </a:spcAft>
               <a:buSzPct val="100000"/>
               <a:buChar char="•"/>
             </a:pPr>
             <a:r>
-              <a:rPr lang="en-US" sz="1400" dirty="0">
+              <a:rPr lang="en-US" sz="1600" dirty="0">
                 <a:solidFill>
                   <a:srgbClr val="3D3A36"/>
                 </a:solidFill>
@@ -1823,20 +2224,20 @@
                 <a:ea typeface="Calibri" pitchFamily="34" charset="-122"/>
                 <a:cs typeface="Calibri" pitchFamily="34" charset="-120"/>
               </a:rPr>
-              <a:t>1 kL = 1000 L = 1 m³</a:t>
-            </a:r>
-            <a:endParaRPr lang="en-US" sz="1400" dirty="0"/>
+              <a:t>They measure the same thing in different units!</a:t>
+            </a:r>
+            <a:endParaRPr lang="en-US" sz="1600" dirty="0"/>
           </a:p>
           <a:p>
             <a:pPr marL="342900" indent="-342900">
               <a:spcAft>
-                <a:spcPts val="600"/>
+                <a:spcPts val="800"/>
               </a:spcAft>
               <a:buSzPct val="100000"/>
               <a:buChar char="•"/>
             </a:pPr>
             <a:r>
-              <a:rPr lang="en-US" sz="1400" dirty="0">
+              <a:rPr lang="en-US" sz="1600" dirty="0">
                 <a:solidFill>
                   <a:srgbClr val="3D3A36"/>
                 </a:solidFill>
@@ -1844,20 +2245,85 @@
                 <a:ea typeface="Calibri" pitchFamily="34" charset="-122"/>
                 <a:cs typeface="Calibri" pitchFamily="34" charset="-120"/>
               </a:rPr>
-              <a:t>A standard water bottle = 500 mL = 0.5 L</a:t>
-            </a:r>
-            <a:endParaRPr lang="en-US" sz="1400" dirty="0"/>
-          </a:p>
-          <a:p>
-            <a:pPr marL="342900" indent="-342900">
-              <a:spcAft>
-                <a:spcPts val="600"/>
-              </a:spcAft>
-              <a:buSzPct val="100000"/>
-              <a:buChar char="•"/>
+              <a:t>The key: 1 cm³ = 1 mL.</a:t>
+            </a:r>
+            <a:endParaRPr lang="en-US" sz="1600" dirty="0"/>
+          </a:p>
+        </p:txBody>
+      </p:sp>
+      <p:sp>
+        <p:nvSpPr>
+          <p:cNvPr id="6" name="Shape 4"/>
+          <p:cNvSpPr/>
+          <p:nvPr/>
+        </p:nvSpPr>
+        <p:spPr>
+          <a:xfrm>
+            <a:off x="640080" y="4114800"/>
+            <a:ext cx="7863840" cy="731520"/>
+          </a:xfrm>
+          <a:prstGeom prst="rect">
+            <a:avLst/>
+          </a:prstGeom>
+          <a:solidFill>
+            <a:srgbClr val="E8F5F3"/>
+          </a:solidFill>
+          <a:ln/>
+          <a:effectLst>
+            <a:outerShdw sx="100000" sy="100000" kx="0" ky="0" algn="bl" rotWithShape="0" blurRad="76200" dist="25400" dir="8100000">
+              <a:srgbClr val="000000">
+                <a:alpha val="12000"/>
+              </a:srgbClr>
+            </a:outerShdw>
+          </a:effectLst>
+        </p:spPr>
+      </p:sp>
+      <p:sp>
+        <p:nvSpPr>
+          <p:cNvPr id="7" name="Shape 5"/>
+          <p:cNvSpPr/>
+          <p:nvPr/>
+        </p:nvSpPr>
+        <p:spPr>
+          <a:xfrm>
+            <a:off x="640080" y="4114800"/>
+            <a:ext cx="64008" cy="731520"/>
+          </a:xfrm>
+          <a:prstGeom prst="rect">
+            <a:avLst/>
+          </a:prstGeom>
+          <a:solidFill>
+            <a:srgbClr val="2A9D8F"/>
+          </a:solidFill>
+          <a:ln/>
+        </p:spPr>
+      </p:sp>
+      <p:sp>
+        <p:nvSpPr>
+          <p:cNvPr id="8" name="Text 6"/>
+          <p:cNvSpPr/>
+          <p:nvPr/>
+        </p:nvSpPr>
+        <p:spPr>
+          <a:xfrm>
+            <a:off x="914400" y="4160520"/>
+            <a:ext cx="7406640" cy="640080"/>
+          </a:xfrm>
+          <a:prstGeom prst="rect">
+            <a:avLst/>
+          </a:prstGeom>
+          <a:noFill/>
+          <a:ln/>
+        </p:spPr>
+        <p:txBody>
+          <a:bodyPr wrap="square" rtlCol="0" anchor="ctr"/>
+          <a:lstStyle/>
+          <a:p>
+            <a:pPr indent="0" marL="0">
+              <a:buNone/>
             </a:pPr>
             <a:r>
-              <a:rPr lang="en-US" sz="1400" dirty="0">
+              <a:rPr lang="en-US" sz="1300" i="1" dirty="0">
                 <a:solidFill>
                   <a:srgbClr val="3D3A36"/>
                 </a:solidFill>
@@ -1865,253 +2331,9 @@
                 <a:ea typeface="Calibri" pitchFamily="34" charset="-122"/>
                 <a:cs typeface="Calibri" pitchFamily="34" charset="-120"/>
               </a:rPr>
-              <a:t>A bathtub ≈ 300 L</a:t>
-            </a:r>
-            <a:endParaRPr lang="en-US" sz="1400" dirty="0"/>
-          </a:p>
-          <a:p>
-            <a:pPr marL="342900" indent="-342900">
-              <a:spcAft>
-                <a:spcPts val="600"/>
-              </a:spcAft>
-              <a:buSzPct val="100000"/>
-              <a:buChar char="•"/>
-            </a:pPr>
-            <a:r>
-              <a:rPr lang="en-US" sz="1400" dirty="0">
-                <a:solidFill>
-                  <a:srgbClr val="3D3A36"/>
-                </a:solidFill>
-                <a:latin typeface="Calibri" pitchFamily="34" charset="0"/>
-                <a:ea typeface="Calibri" pitchFamily="34" charset="-122"/>
-                <a:cs typeface="Calibri" pitchFamily="34" charset="-120"/>
-              </a:rPr>
-              <a:t>An Olympic pool = 2,500,000 L = 2,500 kL</a:t>
-            </a:r>
-            <a:endParaRPr lang="en-US" sz="1400" dirty="0"/>
-          </a:p>
-        </p:txBody>
-      </p:sp>
-      <p:sp>
-        <p:nvSpPr>
-          <p:cNvPr id="6" name="Shape 4"/>
-          <p:cNvSpPr/>
-          <p:nvPr/>
-        </p:nvSpPr>
-        <p:spPr>
-          <a:xfrm>
-            <a:off x="4846320" y="1188720"/>
-            <a:ext cx="3840480" cy="3474720"/>
-          </a:xfrm>
-          <a:prstGeom prst="rect">
-            <a:avLst/>
-          </a:prstGeom>
-          <a:solidFill>
-            <a:srgbClr val="FFFFFF"/>
-          </a:solidFill>
-          <a:ln w="12700">
-            <a:solidFill>
-              <a:srgbClr val="E5E2DC"/>
-            </a:solidFill>
-            <a:prstDash val="solid"/>
-          </a:ln>
-          <a:effectLst>
-            <a:outerShdw sx="100000" sy="100000" kx="0" ky="0" algn="bl" rotWithShape="0" blurRad="50800" dist="25400" dir="8100000">
-              <a:srgbClr val="000000">
-                <a:alpha val="10000"/>
-              </a:srgbClr>
-            </a:outerShdw>
-          </a:effectLst>
-        </p:spPr>
-      </p:sp>
-      <p:sp>
-        <p:nvSpPr>
-          <p:cNvPr id="7" name="Shape 5"/>
-          <p:cNvSpPr/>
-          <p:nvPr/>
-        </p:nvSpPr>
-        <p:spPr>
-          <a:xfrm>
-            <a:off x="4846320" y="1188720"/>
-            <a:ext cx="3840480" cy="54864"/>
-          </a:xfrm>
-          <a:prstGeom prst="rect">
-            <a:avLst/>
-          </a:prstGeom>
-          <a:solidFill>
-            <a:srgbClr val="2A9D8F"/>
-          </a:solidFill>
-          <a:ln/>
-        </p:spPr>
-      </p:sp>
-      <p:sp>
-        <p:nvSpPr>
-          <p:cNvPr id="8" name="Text 6"/>
-          <p:cNvSpPr/>
-          <p:nvPr/>
-        </p:nvSpPr>
-        <p:spPr>
-          <a:xfrm>
-            <a:off x="5120640" y="1371600"/>
-            <a:ext cx="3291840" cy="3108960"/>
-          </a:xfrm>
-          <a:prstGeom prst="rect">
-            <a:avLst/>
-          </a:prstGeom>
-          <a:noFill/>
-          <a:ln/>
-        </p:spPr>
-        <p:txBody>
-          <a:bodyPr wrap="square" rtlCol="0" anchor="t"/>
-          <a:lstStyle/>
-          <a:p>
-            <a:pPr indent="0" marL="0">
-              <a:spcAft>
-                <a:spcPts val="400"/>
-              </a:spcAft>
-              <a:buNone/>
-            </a:pPr>
-            <a:r>
-              <a:rPr lang="en-US" sz="1600" b="1" dirty="0">
-                <a:solidFill>
-                  <a:srgbClr val="1B2A4A"/>
-                </a:solidFill>
-                <a:latin typeface="Calibri" pitchFamily="34" charset="0"/>
-                <a:ea typeface="Calibri" pitchFamily="34" charset="-122"/>
-                <a:cs typeface="Calibri" pitchFamily="34" charset="-120"/>
-              </a:rPr>
-              <a:t>Measuring Capacity</a:t>
-            </a:r>
-            <a:endParaRPr lang="en-US" sz="1600" dirty="0"/>
-          </a:p>
-          <a:p>
-            <a:pPr indent="0" marL="0">
-              <a:spcAft>
-                <a:spcPts val="400"/>
-              </a:spcAft>
-              <a:buNone/>
-            </a:pPr>
-            <a:endParaRPr lang="en-US" sz="1600" dirty="0"/>
-          </a:p>
-          <a:p>
-            <a:pPr indent="0" marL="0">
-              <a:spcAft>
-                <a:spcPts val="400"/>
-              </a:spcAft>
-              <a:buNone/>
-            </a:pPr>
-            <a:r>
-              <a:rPr lang="en-US" sz="1300" dirty="0">
-                <a:solidFill>
-                  <a:srgbClr val="3D3A36"/>
-                </a:solidFill>
-                <a:latin typeface="Calibri" pitchFamily="34" charset="0"/>
-                <a:ea typeface="Calibri" pitchFamily="34" charset="-122"/>
-                <a:cs typeface="Calibri" pitchFamily="34" charset="-120"/>
-              </a:rPr>
-              <a:t>Use a measuring cylinder for liquids</a:t>
-            </a:r>
-            <a:endParaRPr lang="en-US" sz="1600" dirty="0"/>
-          </a:p>
-          <a:p>
-            <a:pPr indent="0" marL="0">
-              <a:spcAft>
-                <a:spcPts val="400"/>
-              </a:spcAft>
-              <a:buNone/>
-            </a:pPr>
-            <a:r>
-              <a:rPr lang="en-US" sz="1300" dirty="0">
-                <a:solidFill>
-                  <a:srgbClr val="3D3A36"/>
-                </a:solidFill>
-                <a:latin typeface="Calibri" pitchFamily="34" charset="0"/>
-                <a:ea typeface="Calibri" pitchFamily="34" charset="-122"/>
-                <a:cs typeface="Calibri" pitchFamily="34" charset="-120"/>
-              </a:rPr>
-              <a:t>Read the bottom of the meniscus at eye level</a:t>
-            </a:r>
-            <a:endParaRPr lang="en-US" sz="1600" dirty="0"/>
-          </a:p>
-          <a:p>
-            <a:pPr indent="0" marL="0">
-              <a:spcAft>
-                <a:spcPts val="400"/>
-              </a:spcAft>
-              <a:buNone/>
-            </a:pPr>
-            <a:r>
-              <a:rPr lang="en-US" sz="1300" dirty="0">
-                <a:solidFill>
-                  <a:srgbClr val="3D3A36"/>
-                </a:solidFill>
-                <a:latin typeface="Calibri" pitchFamily="34" charset="0"/>
-                <a:ea typeface="Calibri" pitchFamily="34" charset="-122"/>
-                <a:cs typeface="Calibri" pitchFamily="34" charset="-120"/>
-              </a:rPr>
-              <a:t>Graduated = marked with measurement lines</a:t>
-            </a:r>
-            <a:endParaRPr lang="en-US" sz="1600" dirty="0"/>
-          </a:p>
-          <a:p>
-            <a:pPr indent="0" marL="0">
-              <a:spcAft>
-                <a:spcPts val="400"/>
-              </a:spcAft>
-              <a:buNone/>
-            </a:pPr>
-            <a:r>
-              <a:rPr lang="en-US" sz="1300" dirty="0">
-                <a:solidFill>
-                  <a:srgbClr val="3D3A36"/>
-                </a:solidFill>
-                <a:latin typeface="Calibri" pitchFamily="34" charset="0"/>
-                <a:ea typeface="Calibri" pitchFamily="34" charset="-122"/>
-                <a:cs typeface="Calibri" pitchFamily="34" charset="-120"/>
-              </a:rPr>
-              <a:t>Choose the right container for the amount</a:t>
-            </a:r>
-            <a:endParaRPr lang="en-US" sz="1600" dirty="0"/>
-          </a:p>
-          <a:p>
-            <a:pPr indent="0" marL="0">
-              <a:spcAft>
-                <a:spcPts val="400"/>
-              </a:spcAft>
-              <a:buNone/>
-            </a:pPr>
-            <a:r>
-              <a:rPr lang="en-US" sz="1300" dirty="0">
-                <a:solidFill>
-                  <a:srgbClr val="3D3A36"/>
-                </a:solidFill>
-                <a:latin typeface="Calibri" pitchFamily="34" charset="0"/>
-                <a:ea typeface="Calibri" pitchFamily="34" charset="-122"/>
-                <a:cs typeface="Calibri" pitchFamily="34" charset="-120"/>
-              </a:rPr>
-              <a:t>Small amounts: mL (medicine, cooking)</a:t>
-            </a:r>
-            <a:endParaRPr lang="en-US" sz="1600" dirty="0"/>
-          </a:p>
-          <a:p>
-            <a:pPr indent="0" marL="0">
-              <a:spcAft>
-                <a:spcPts val="400"/>
-              </a:spcAft>
-              <a:buNone/>
-            </a:pPr>
-            <a:r>
-              <a:rPr lang="en-US" sz="1300" dirty="0">
-                <a:solidFill>
-                  <a:srgbClr val="3D3A36"/>
-                </a:solidFill>
-                <a:latin typeface="Calibri" pitchFamily="34" charset="0"/>
-                <a:ea typeface="Calibri" pitchFamily="34" charset="-122"/>
-                <a:cs typeface="Calibri" pitchFamily="34" charset="-120"/>
-              </a:rPr>
-              <a:t>Large amounts: L (petrol, swimming pools)</a:t>
-            </a:r>
-            <a:endParaRPr lang="en-US" sz="1600" dirty="0"/>
+              <a:t>A 1 cm × 1 cm × 1 cm cube holds exactly 1 mL of water.</a:t>
+            </a:r>
+            <a:endParaRPr lang="en-US" sz="1300" dirty="0"/>
           </a:p>
         </p:txBody>
       </p:sp>
@@ -2156,7 +2378,27 @@
         <p:spPr>
           <a:xfrm>
             <a:off x="0" y="0"/>
-            <a:ext cx="9144000" cy="54864"/>
+            <a:ext cx="9144000" cy="822960"/>
+          </a:xfrm>
+          <a:prstGeom prst="rect">
+            <a:avLst/>
+          </a:prstGeom>
+          <a:solidFill>
+            <a:srgbClr val="FFFFFF"/>
+          </a:solidFill>
+          <a:ln/>
+        </p:spPr>
+      </p:sp>
+      <p:sp>
+        <p:nvSpPr>
+          <p:cNvPr id="3" name="Shape 1"/>
+          <p:cNvSpPr/>
+          <p:nvPr/>
+        </p:nvSpPr>
+        <p:spPr>
+          <a:xfrm>
+            <a:off x="0" y="795528"/>
+            <a:ext cx="9144000" cy="27432"/>
           </a:xfrm>
           <a:prstGeom prst="rect">
             <a:avLst/>
@@ -2169,14 +2411,14 @@
       </p:sp>
       <p:sp>
         <p:nvSpPr>
-          <p:cNvPr id="3" name="Text 1"/>
-          <p:cNvSpPr/>
-          <p:nvPr/>
-        </p:nvSpPr>
-        <p:spPr>
-          <a:xfrm>
-            <a:off x="7772400" y="4709160"/>
-            <a:ext cx="1097280" cy="320040"/>
+          <p:cNvPr id="4" name="Text 2"/>
+          <p:cNvSpPr/>
+          <p:nvPr/>
+        </p:nvSpPr>
+        <p:spPr>
+          <a:xfrm>
+            <a:off x="640080" y="91440"/>
+            <a:ext cx="7863840" cy="640080"/>
           </a:xfrm>
           <a:prstGeom prst="rect">
             <a:avLst/>
@@ -2185,53 +2427,14 @@
           <a:ln/>
         </p:spPr>
         <p:txBody>
-          <a:bodyPr wrap="square" rtlCol="0" anchor="ctr"/>
-          <a:lstStyle/>
-          <a:p>
-            <a:pPr algn="r" indent="0" marL="0">
-              <a:buNone/>
-            </a:pPr>
-            <a:r>
-              <a:rPr lang="en-US" sz="900" dirty="0">
-                <a:solidFill>
-                  <a:srgbClr val="6B6660"/>
-                </a:solidFill>
-                <a:latin typeface="Calibri" pitchFamily="34" charset="0"/>
-                <a:ea typeface="Calibri" pitchFamily="34" charset="-122"/>
-                <a:cs typeface="Calibri" pitchFamily="34" charset="-120"/>
-              </a:rPr>
-              <a:t>4 / 5</a:t>
-            </a:r>
-            <a:endParaRPr lang="en-US" sz="900" dirty="0"/>
-          </a:p>
-        </p:txBody>
-      </p:sp>
-      <p:sp>
-        <p:nvSpPr>
-          <p:cNvPr id="4" name="Text 2"/>
-          <p:cNvSpPr/>
-          <p:nvPr/>
-        </p:nvSpPr>
-        <p:spPr>
-          <a:xfrm>
-            <a:off x="457200" y="274320"/>
-            <a:ext cx="8229600" cy="640080"/>
-          </a:xfrm>
-          <a:prstGeom prst="rect">
-            <a:avLst/>
-          </a:prstGeom>
-          <a:noFill/>
-          <a:ln/>
-        </p:spPr>
-        <p:txBody>
-          <a:bodyPr wrap="square" rtlCol="0" anchor="ctr"/>
+          <a:bodyPr wrap="square" lIns="0" tIns="0" rIns="0" bIns="0" rtlCol="0" anchor="ctr"/>
           <a:lstStyle/>
           <a:p>
             <a:pPr indent="0" marL="0">
               <a:buNone/>
             </a:pPr>
             <a:r>
-              <a:rPr lang="en-US" sz="2600" b="1" dirty="0">
+              <a:rPr lang="en-US" sz="2200" b="1" dirty="0">
                 <a:solidFill>
                   <a:srgbClr val="1B2A4A"/>
                 </a:solidFill>
@@ -2239,139 +2442,1037 @@
                 <a:ea typeface="Georgia" pitchFamily="34" charset="-122"/>
                 <a:cs typeface="Georgia" pitchFamily="34" charset="-120"/>
               </a:rPr>
-              <a:t>Real-World Problems</a:t>
-            </a:r>
-            <a:endParaRPr lang="en-US" sz="2600" dirty="0"/>
-          </a:p>
-        </p:txBody>
-      </p:sp>
-      <p:sp>
-        <p:nvSpPr>
-          <p:cNvPr id="5" name="Text 3"/>
-          <p:cNvSpPr/>
-          <p:nvPr/>
-        </p:nvSpPr>
-        <p:spPr>
-          <a:xfrm>
-            <a:off x="457200" y="1097280"/>
-            <a:ext cx="8229600" cy="3657600"/>
-          </a:xfrm>
-          <a:prstGeom prst="rect">
-            <a:avLst/>
-          </a:prstGeom>
-          <a:noFill/>
-          <a:ln/>
-        </p:spPr>
-        <p:txBody>
-          <a:bodyPr wrap="square" rtlCol="0" anchor="t"/>
-          <a:lstStyle/>
-          <a:p>
-            <a:pPr marL="342900" indent="-342900">
-              <a:spcAft>
-                <a:spcPts val="800"/>
-              </a:spcAft>
-              <a:buSzPct val="100000"/>
-              <a:buChar char="•"/>
-            </a:pPr>
-            <a:r>
-              <a:rPr lang="en-US" sz="1400" dirty="0">
-                <a:solidFill>
-                  <a:srgbClr val="3D3A36"/>
-                </a:solidFill>
-                <a:latin typeface="Calibri" pitchFamily="34" charset="0"/>
-                <a:ea typeface="Calibri" pitchFamily="34" charset="-122"/>
-                <a:cs typeface="Calibri" pitchFamily="34" charset="-120"/>
-              </a:rPr>
-              <a:t>A fish tank is 60cm × 30cm × 40cm. Volume = 72,000 cm³ = 72,000 mL = 72 L</a:t>
-            </a:r>
-            <a:endParaRPr lang="en-US" sz="1400" dirty="0"/>
-          </a:p>
-          <a:p>
-            <a:pPr marL="342900" indent="-342900">
-              <a:spcAft>
-                <a:spcPts val="800"/>
-              </a:spcAft>
-              <a:buSzPct val="100000"/>
-              <a:buChar char="•"/>
-            </a:pPr>
-            <a:r>
-              <a:rPr lang="en-US" sz="1400" dirty="0">
-                <a:solidFill>
-                  <a:srgbClr val="3D3A36"/>
-                </a:solidFill>
-                <a:latin typeface="Calibri" pitchFamily="34" charset="0"/>
-                <a:ea typeface="Calibri" pitchFamily="34" charset="-122"/>
-                <a:cs typeface="Calibri" pitchFamily="34" charset="-120"/>
-              </a:rPr>
-              <a:t>A jug holds 1.5 L. How many 250 mL glasses can it fill? 1500 ÷ 250 = 6 glasses</a:t>
-            </a:r>
-            <a:endParaRPr lang="en-US" sz="1400" dirty="0"/>
-          </a:p>
-          <a:p>
-            <a:pPr marL="342900" indent="-342900">
-              <a:spcAft>
-                <a:spcPts val="800"/>
-              </a:spcAft>
-              <a:buSzPct val="100000"/>
-              <a:buChar char="•"/>
-            </a:pPr>
-            <a:r>
-              <a:rPr lang="en-US" sz="1400" dirty="0">
-                <a:solidFill>
-                  <a:srgbClr val="3D3A36"/>
-                </a:solidFill>
-                <a:latin typeface="Calibri" pitchFamily="34" charset="0"/>
-                <a:ea typeface="Calibri" pitchFamily="34" charset="-122"/>
-                <a:cs typeface="Calibri" pitchFamily="34" charset="-120"/>
-              </a:rPr>
-              <a:t>A swimming pool is 25m × 10m × 2m = 500 m³ = 500,000 L</a:t>
-            </a:r>
-            <a:endParaRPr lang="en-US" sz="1400" dirty="0"/>
-          </a:p>
-          <a:p>
-            <a:pPr marL="342900" indent="-342900">
-              <a:spcAft>
-                <a:spcPts val="800"/>
-              </a:spcAft>
-              <a:buSzPct val="100000"/>
-              <a:buChar char="•"/>
-            </a:pPr>
-            <a:r>
-              <a:rPr lang="en-US" sz="1400" dirty="0">
-                <a:solidFill>
-                  <a:srgbClr val="3D3A36"/>
-                </a:solidFill>
-                <a:latin typeface="Calibri" pitchFamily="34" charset="0"/>
-                <a:ea typeface="Calibri" pitchFamily="34" charset="-122"/>
-                <a:cs typeface="Calibri" pitchFamily="34" charset="-120"/>
-              </a:rPr>
-              <a:t>Always convert to the same unit before calculating</a:t>
-            </a:r>
-            <a:endParaRPr lang="en-US" sz="1400" dirty="0"/>
-          </a:p>
-          <a:p>
-            <a:pPr marL="342900" indent="-342900">
-              <a:spcAft>
-                <a:spcPts val="800"/>
-              </a:spcAft>
-              <a:buSzPct val="100000"/>
-              <a:buChar char="•"/>
-            </a:pPr>
-            <a:r>
-              <a:rPr lang="en-US" sz="1400" dirty="0">
-                <a:solidFill>
-                  <a:srgbClr val="3D3A36"/>
-                </a:solidFill>
-                <a:latin typeface="Calibri" pitchFamily="34" charset="0"/>
-                <a:ea typeface="Calibri" pitchFamily="34" charset="-122"/>
-                <a:cs typeface="Calibri" pitchFamily="34" charset="-120"/>
-              </a:rPr>
-              <a:t>State your answer with the correct unit (L, mL, cm³, m³)</a:t>
-            </a:r>
-            <a:endParaRPr lang="en-US" sz="1400" dirty="0"/>
-          </a:p>
-        </p:txBody>
-      </p:sp>
+              <a:t>Unit Conversions</a:t>
+            </a:r>
+            <a:endParaRPr lang="en-US" sz="2200" dirty="0"/>
+          </a:p>
+        </p:txBody>
+      </p:sp>
+      <p:graphicFrame>
+        <p:nvGraphicFramePr>
+          <p:cNvPr id="5" name="Table 0"/>
+          <p:cNvGraphicFramePr>
+            <a:graphicFrameLocks noGrp="1"/>
+          </p:cNvGraphicFramePr>
+          <p:nvPr>
+            <p:extLst>
+              <p:ext uri="{D42A27DB-BD31-4B8C-83A1-F6EECF244321}">
+                <p14:modId xmlns:p14="http://schemas.microsoft.com/office/powerpoint/2010/main" val="1579011935"/>
+              </p:ext>
+            </p:extLst>
+          </p:nvPr>
+        </p:nvGraphicFramePr>
+        <p:xfrm>
+          <a:off x="640080" y="1051560"/>
+          <a:ext cx="7863840" cy="914400"/>
+        </p:xfrm>
+        <a:graphic>
+          <a:graphicData uri="http://schemas.openxmlformats.org/drawingml/2006/table">
+            <a:tbl>
+              <a:tblPr/>
+              <a:tblGrid>
+                <a:gridCol w="2621280"/>
+                <a:gridCol w="2621280"/>
+                <a:gridCol w="2621280"/>
+              </a:tblGrid>
+              <a:tr h="502920">
+                <a:tc>
+                  <a:txBody>
+                    <a:bodyPr/>
+                    <a:lstStyle/>
+                    <a:p>
+                      <a:pPr indent="0" marL="0">
+                        <a:buNone/>
+                      </a:pPr>
+                      <a:r>
+                        <a:rPr lang="en-US" sz="1300" b="1" dirty="0">
+                          <a:solidFill>
+                            <a:srgbClr val="FFFFFF"/>
+                          </a:solidFill>
+                          <a:latin typeface="Calibri" pitchFamily="34" charset="0"/>
+                          <a:ea typeface="Calibri" pitchFamily="34" charset="-122"/>
+                          <a:cs typeface="Calibri" pitchFamily="34" charset="-120"/>
+                        </a:rPr>
+                        <a:t>From</a:t>
+                      </a:r>
+                      <a:endParaRPr lang="en-US" sz="1300" dirty="0">
+                        <a:latin typeface="Calibri" charset="0"/>
+                        <a:ea typeface="Calibri" charset="0"/>
+                        <a:cs typeface="Calibri" charset="0"/>
+                      </a:endParaRPr>
+                    </a:p>
+                  </a:txBody>
+                  <a:tcPr marL="91440" marR="91440" marT="45720" marB="45720">
+                    <a:lnL w="6350" cap="flat" cmpd="sng" algn="ctr">
+                      <a:solidFill>
+                        <a:srgbClr val="E5E2DC"/>
+                      </a:solidFill>
+                      <a:prstDash val="solid"/>
+                      <a:round/>
+                      <a:headEnd type="none" w="med" len="med"/>
+                      <a:tailEnd type="none" w="med" len="med"/>
+                    </a:lnL>
+                    <a:lnR w="6350" cap="flat" cmpd="sng" algn="ctr">
+                      <a:solidFill>
+                        <a:srgbClr val="E5E2DC"/>
+                      </a:solidFill>
+                      <a:prstDash val="solid"/>
+                      <a:round/>
+                      <a:headEnd type="none" w="med" len="med"/>
+                      <a:tailEnd type="none" w="med" len="med"/>
+                    </a:lnR>
+                    <a:lnT w="6350" cap="flat" cmpd="sng" algn="ctr">
+                      <a:solidFill>
+                        <a:srgbClr val="E5E2DC"/>
+                      </a:solidFill>
+                      <a:prstDash val="solid"/>
+                      <a:round/>
+                      <a:headEnd type="none" w="med" len="med"/>
+                      <a:tailEnd type="none" w="med" len="med"/>
+                    </a:lnT>
+                    <a:lnB w="6350" cap="flat" cmpd="sng" algn="ctr">
+                      <a:solidFill>
+                        <a:srgbClr val="E5E2DC"/>
+                      </a:solidFill>
+                      <a:prstDash val="solid"/>
+                      <a:round/>
+                      <a:headEnd type="none" w="med" len="med"/>
+                      <a:tailEnd type="none" w="med" len="med"/>
+                    </a:lnB>
+                    <a:solidFill>
+                      <a:srgbClr val="2A9D8F"/>
+                    </a:solidFill>
+                  </a:tcPr>
+                </a:tc>
+                <a:tc>
+                  <a:txBody>
+                    <a:bodyPr/>
+                    <a:lstStyle/>
+                    <a:p>
+                      <a:pPr indent="0" marL="0">
+                        <a:buNone/>
+                      </a:pPr>
+                      <a:r>
+                        <a:rPr lang="en-US" sz="1300" b="1" dirty="0">
+                          <a:solidFill>
+                            <a:srgbClr val="FFFFFF"/>
+                          </a:solidFill>
+                          <a:latin typeface="Calibri" pitchFamily="34" charset="0"/>
+                          <a:ea typeface="Calibri" pitchFamily="34" charset="-122"/>
+                          <a:cs typeface="Calibri" pitchFamily="34" charset="-120"/>
+                        </a:rPr>
+                        <a:t>To</a:t>
+                      </a:r>
+                      <a:endParaRPr lang="en-US" sz="1300" dirty="0">
+                        <a:latin typeface="Calibri" charset="0"/>
+                        <a:ea typeface="Calibri" charset="0"/>
+                        <a:cs typeface="Calibri" charset="0"/>
+                      </a:endParaRPr>
+                    </a:p>
+                  </a:txBody>
+                  <a:tcPr marL="91440" marR="91440" marT="45720" marB="45720">
+                    <a:lnL w="6350" cap="flat" cmpd="sng" algn="ctr">
+                      <a:solidFill>
+                        <a:srgbClr val="E5E2DC"/>
+                      </a:solidFill>
+                      <a:prstDash val="solid"/>
+                      <a:round/>
+                      <a:headEnd type="none" w="med" len="med"/>
+                      <a:tailEnd type="none" w="med" len="med"/>
+                    </a:lnL>
+                    <a:lnR w="6350" cap="flat" cmpd="sng" algn="ctr">
+                      <a:solidFill>
+                        <a:srgbClr val="E5E2DC"/>
+                      </a:solidFill>
+                      <a:prstDash val="solid"/>
+                      <a:round/>
+                      <a:headEnd type="none" w="med" len="med"/>
+                      <a:tailEnd type="none" w="med" len="med"/>
+                    </a:lnR>
+                    <a:lnT w="6350" cap="flat" cmpd="sng" algn="ctr">
+                      <a:solidFill>
+                        <a:srgbClr val="E5E2DC"/>
+                      </a:solidFill>
+                      <a:prstDash val="solid"/>
+                      <a:round/>
+                      <a:headEnd type="none" w="med" len="med"/>
+                      <a:tailEnd type="none" w="med" len="med"/>
+                    </a:lnT>
+                    <a:lnB w="6350" cap="flat" cmpd="sng" algn="ctr">
+                      <a:solidFill>
+                        <a:srgbClr val="E5E2DC"/>
+                      </a:solidFill>
+                      <a:prstDash val="solid"/>
+                      <a:round/>
+                      <a:headEnd type="none" w="med" len="med"/>
+                      <a:tailEnd type="none" w="med" len="med"/>
+                    </a:lnB>
+                    <a:solidFill>
+                      <a:srgbClr val="2A9D8F"/>
+                    </a:solidFill>
+                  </a:tcPr>
+                </a:tc>
+                <a:tc>
+                  <a:txBody>
+                    <a:bodyPr/>
+                    <a:lstStyle/>
+                    <a:p>
+                      <a:pPr indent="0" marL="0">
+                        <a:buNone/>
+                      </a:pPr>
+                      <a:r>
+                        <a:rPr lang="en-US" sz="1300" b="1" dirty="0">
+                          <a:solidFill>
+                            <a:srgbClr val="FFFFFF"/>
+                          </a:solidFill>
+                          <a:latin typeface="Calibri" pitchFamily="34" charset="0"/>
+                          <a:ea typeface="Calibri" pitchFamily="34" charset="-122"/>
+                          <a:cs typeface="Calibri" pitchFamily="34" charset="-120"/>
+                        </a:rPr>
+                        <a:t>Rule</a:t>
+                      </a:r>
+                      <a:endParaRPr lang="en-US" sz="1300" dirty="0">
+                        <a:latin typeface="Calibri" charset="0"/>
+                        <a:ea typeface="Calibri" charset="0"/>
+                        <a:cs typeface="Calibri" charset="0"/>
+                      </a:endParaRPr>
+                    </a:p>
+                  </a:txBody>
+                  <a:tcPr marL="91440" marR="91440" marT="45720" marB="45720">
+                    <a:lnL w="6350" cap="flat" cmpd="sng" algn="ctr">
+                      <a:solidFill>
+                        <a:srgbClr val="E5E2DC"/>
+                      </a:solidFill>
+                      <a:prstDash val="solid"/>
+                      <a:round/>
+                      <a:headEnd type="none" w="med" len="med"/>
+                      <a:tailEnd type="none" w="med" len="med"/>
+                    </a:lnL>
+                    <a:lnR w="6350" cap="flat" cmpd="sng" algn="ctr">
+                      <a:solidFill>
+                        <a:srgbClr val="E5E2DC"/>
+                      </a:solidFill>
+                      <a:prstDash val="solid"/>
+                      <a:round/>
+                      <a:headEnd type="none" w="med" len="med"/>
+                      <a:tailEnd type="none" w="med" len="med"/>
+                    </a:lnR>
+                    <a:lnT w="6350" cap="flat" cmpd="sng" algn="ctr">
+                      <a:solidFill>
+                        <a:srgbClr val="E5E2DC"/>
+                      </a:solidFill>
+                      <a:prstDash val="solid"/>
+                      <a:round/>
+                      <a:headEnd type="none" w="med" len="med"/>
+                      <a:tailEnd type="none" w="med" len="med"/>
+                    </a:lnT>
+                    <a:lnB w="6350" cap="flat" cmpd="sng" algn="ctr">
+                      <a:solidFill>
+                        <a:srgbClr val="E5E2DC"/>
+                      </a:solidFill>
+                      <a:prstDash val="solid"/>
+                      <a:round/>
+                      <a:headEnd type="none" w="med" len="med"/>
+                      <a:tailEnd type="none" w="med" len="med"/>
+                    </a:lnB>
+                    <a:solidFill>
+                      <a:srgbClr val="2A9D8F"/>
+                    </a:solidFill>
+                  </a:tcPr>
+                </a:tc>
+              </a:tr>
+              <a:tr h="502920">
+                <a:tc>
+                  <a:txBody>
+                    <a:bodyPr/>
+                    <a:lstStyle/>
+                    <a:p>
+                      <a:pPr indent="0" marL="0">
+                        <a:buNone/>
+                      </a:pPr>
+                      <a:r>
+                        <a:rPr lang="en-US" sz="1300" dirty="0">
+                          <a:solidFill>
+                            <a:srgbClr val="3D3A36"/>
+                          </a:solidFill>
+                          <a:latin typeface="Calibri" pitchFamily="34" charset="0"/>
+                          <a:ea typeface="Calibri" pitchFamily="34" charset="-122"/>
+                          <a:cs typeface="Calibri" pitchFamily="34" charset="-120"/>
+                        </a:rPr>
+                        <a:t>1 cm³</a:t>
+                      </a:r>
+                      <a:endParaRPr lang="en-US" sz="1300" dirty="0">
+                        <a:latin typeface="Calibri" charset="0"/>
+                        <a:ea typeface="Calibri" charset="0"/>
+                        <a:cs typeface="Calibri" charset="0"/>
+                      </a:endParaRPr>
+                    </a:p>
+                  </a:txBody>
+                  <a:tcPr marL="91440" marR="91440" marT="45720" marB="45720">
+                    <a:lnL w="6350" cap="flat" cmpd="sng" algn="ctr">
+                      <a:solidFill>
+                        <a:srgbClr val="E5E2DC"/>
+                      </a:solidFill>
+                      <a:prstDash val="solid"/>
+                      <a:round/>
+                      <a:headEnd type="none" w="med" len="med"/>
+                      <a:tailEnd type="none" w="med" len="med"/>
+                    </a:lnL>
+                    <a:lnR w="6350" cap="flat" cmpd="sng" algn="ctr">
+                      <a:solidFill>
+                        <a:srgbClr val="E5E2DC"/>
+                      </a:solidFill>
+                      <a:prstDash val="solid"/>
+                      <a:round/>
+                      <a:headEnd type="none" w="med" len="med"/>
+                      <a:tailEnd type="none" w="med" len="med"/>
+                    </a:lnR>
+                    <a:lnT w="6350" cap="flat" cmpd="sng" algn="ctr">
+                      <a:solidFill>
+                        <a:srgbClr val="E5E2DC"/>
+                      </a:solidFill>
+                      <a:prstDash val="solid"/>
+                      <a:round/>
+                      <a:headEnd type="none" w="med" len="med"/>
+                      <a:tailEnd type="none" w="med" len="med"/>
+                    </a:lnT>
+                    <a:lnB w="6350" cap="flat" cmpd="sng" algn="ctr">
+                      <a:solidFill>
+                        <a:srgbClr val="E5E2DC"/>
+                      </a:solidFill>
+                      <a:prstDash val="solid"/>
+                      <a:round/>
+                      <a:headEnd type="none" w="med" len="med"/>
+                      <a:tailEnd type="none" w="med" len="med"/>
+                    </a:lnB>
+                  </a:tcPr>
+                </a:tc>
+                <a:tc>
+                  <a:txBody>
+                    <a:bodyPr/>
+                    <a:lstStyle/>
+                    <a:p>
+                      <a:pPr indent="0" marL="0">
+                        <a:buNone/>
+                      </a:pPr>
+                      <a:r>
+                        <a:rPr lang="en-US" sz="1300" dirty="0">
+                          <a:solidFill>
+                            <a:srgbClr val="3D3A36"/>
+                          </a:solidFill>
+                          <a:latin typeface="Calibri" pitchFamily="34" charset="0"/>
+                          <a:ea typeface="Calibri" pitchFamily="34" charset="-122"/>
+                          <a:cs typeface="Calibri" pitchFamily="34" charset="-120"/>
+                        </a:rPr>
+                        <a:t>1 mL</a:t>
+                      </a:r>
+                      <a:endParaRPr lang="en-US" sz="1300" dirty="0">
+                        <a:latin typeface="Calibri" charset="0"/>
+                        <a:ea typeface="Calibri" charset="0"/>
+                        <a:cs typeface="Calibri" charset="0"/>
+                      </a:endParaRPr>
+                    </a:p>
+                  </a:txBody>
+                  <a:tcPr marL="91440" marR="91440" marT="45720" marB="45720">
+                    <a:lnL w="6350" cap="flat" cmpd="sng" algn="ctr">
+                      <a:solidFill>
+                        <a:srgbClr val="E5E2DC"/>
+                      </a:solidFill>
+                      <a:prstDash val="solid"/>
+                      <a:round/>
+                      <a:headEnd type="none" w="med" len="med"/>
+                      <a:tailEnd type="none" w="med" len="med"/>
+                    </a:lnL>
+                    <a:lnR w="6350" cap="flat" cmpd="sng" algn="ctr">
+                      <a:solidFill>
+                        <a:srgbClr val="E5E2DC"/>
+                      </a:solidFill>
+                      <a:prstDash val="solid"/>
+                      <a:round/>
+                      <a:headEnd type="none" w="med" len="med"/>
+                      <a:tailEnd type="none" w="med" len="med"/>
+                    </a:lnR>
+                    <a:lnT w="6350" cap="flat" cmpd="sng" algn="ctr">
+                      <a:solidFill>
+                        <a:srgbClr val="E5E2DC"/>
+                      </a:solidFill>
+                      <a:prstDash val="solid"/>
+                      <a:round/>
+                      <a:headEnd type="none" w="med" len="med"/>
+                      <a:tailEnd type="none" w="med" len="med"/>
+                    </a:lnT>
+                    <a:lnB w="6350" cap="flat" cmpd="sng" algn="ctr">
+                      <a:solidFill>
+                        <a:srgbClr val="E5E2DC"/>
+                      </a:solidFill>
+                      <a:prstDash val="solid"/>
+                      <a:round/>
+                      <a:headEnd type="none" w="med" len="med"/>
+                      <a:tailEnd type="none" w="med" len="med"/>
+                    </a:lnB>
+                  </a:tcPr>
+                </a:tc>
+                <a:tc>
+                  <a:txBody>
+                    <a:bodyPr/>
+                    <a:lstStyle/>
+                    <a:p>
+                      <a:pPr indent="0" marL="0">
+                        <a:buNone/>
+                      </a:pPr>
+                      <a:r>
+                        <a:rPr lang="en-US" sz="1300" dirty="0">
+                          <a:solidFill>
+                            <a:srgbClr val="3D3A36"/>
+                          </a:solidFill>
+                          <a:latin typeface="Calibri" pitchFamily="34" charset="0"/>
+                          <a:ea typeface="Calibri" pitchFamily="34" charset="-122"/>
+                          <a:cs typeface="Calibri" pitchFamily="34" charset="-120"/>
+                        </a:rPr>
+                        <a:t>They are equal</a:t>
+                      </a:r>
+                      <a:endParaRPr lang="en-US" sz="1300" dirty="0">
+                        <a:latin typeface="Calibri" charset="0"/>
+                        <a:ea typeface="Calibri" charset="0"/>
+                        <a:cs typeface="Calibri" charset="0"/>
+                      </a:endParaRPr>
+                    </a:p>
+                  </a:txBody>
+                  <a:tcPr marL="91440" marR="91440" marT="45720" marB="45720">
+                    <a:lnL w="6350" cap="flat" cmpd="sng" algn="ctr">
+                      <a:solidFill>
+                        <a:srgbClr val="E5E2DC"/>
+                      </a:solidFill>
+                      <a:prstDash val="solid"/>
+                      <a:round/>
+                      <a:headEnd type="none" w="med" len="med"/>
+                      <a:tailEnd type="none" w="med" len="med"/>
+                    </a:lnL>
+                    <a:lnR w="6350" cap="flat" cmpd="sng" algn="ctr">
+                      <a:solidFill>
+                        <a:srgbClr val="E5E2DC"/>
+                      </a:solidFill>
+                      <a:prstDash val="solid"/>
+                      <a:round/>
+                      <a:headEnd type="none" w="med" len="med"/>
+                      <a:tailEnd type="none" w="med" len="med"/>
+                    </a:lnR>
+                    <a:lnT w="6350" cap="flat" cmpd="sng" algn="ctr">
+                      <a:solidFill>
+                        <a:srgbClr val="E5E2DC"/>
+                      </a:solidFill>
+                      <a:prstDash val="solid"/>
+                      <a:round/>
+                      <a:headEnd type="none" w="med" len="med"/>
+                      <a:tailEnd type="none" w="med" len="med"/>
+                    </a:lnT>
+                    <a:lnB w="6350" cap="flat" cmpd="sng" algn="ctr">
+                      <a:solidFill>
+                        <a:srgbClr val="E5E2DC"/>
+                      </a:solidFill>
+                      <a:prstDash val="solid"/>
+                      <a:round/>
+                      <a:headEnd type="none" w="med" len="med"/>
+                      <a:tailEnd type="none" w="med" len="med"/>
+                    </a:lnB>
+                  </a:tcPr>
+                </a:tc>
+              </a:tr>
+              <a:tr h="502920">
+                <a:tc>
+                  <a:txBody>
+                    <a:bodyPr/>
+                    <a:lstStyle/>
+                    <a:p>
+                      <a:pPr indent="0" marL="0">
+                        <a:buNone/>
+                      </a:pPr>
+                      <a:r>
+                        <a:rPr lang="en-US" sz="1300" dirty="0">
+                          <a:solidFill>
+                            <a:srgbClr val="3D3A36"/>
+                          </a:solidFill>
+                          <a:latin typeface="Calibri" pitchFamily="34" charset="0"/>
+                          <a:ea typeface="Calibri" pitchFamily="34" charset="-122"/>
+                          <a:cs typeface="Calibri" pitchFamily="34" charset="-120"/>
+                        </a:rPr>
+                        <a:t>1,000 cm³</a:t>
+                      </a:r>
+                      <a:endParaRPr lang="en-US" sz="1300" dirty="0">
+                        <a:latin typeface="Calibri" charset="0"/>
+                        <a:ea typeface="Calibri" charset="0"/>
+                        <a:cs typeface="Calibri" charset="0"/>
+                      </a:endParaRPr>
+                    </a:p>
+                  </a:txBody>
+                  <a:tcPr marL="91440" marR="91440" marT="45720" marB="45720">
+                    <a:lnL w="6350" cap="flat" cmpd="sng" algn="ctr">
+                      <a:solidFill>
+                        <a:srgbClr val="E5E2DC"/>
+                      </a:solidFill>
+                      <a:prstDash val="solid"/>
+                      <a:round/>
+                      <a:headEnd type="none" w="med" len="med"/>
+                      <a:tailEnd type="none" w="med" len="med"/>
+                    </a:lnL>
+                    <a:lnR w="6350" cap="flat" cmpd="sng" algn="ctr">
+                      <a:solidFill>
+                        <a:srgbClr val="E5E2DC"/>
+                      </a:solidFill>
+                      <a:prstDash val="solid"/>
+                      <a:round/>
+                      <a:headEnd type="none" w="med" len="med"/>
+                      <a:tailEnd type="none" w="med" len="med"/>
+                    </a:lnR>
+                    <a:lnT w="6350" cap="flat" cmpd="sng" algn="ctr">
+                      <a:solidFill>
+                        <a:srgbClr val="E5E2DC"/>
+                      </a:solidFill>
+                      <a:prstDash val="solid"/>
+                      <a:round/>
+                      <a:headEnd type="none" w="med" len="med"/>
+                      <a:tailEnd type="none" w="med" len="med"/>
+                    </a:lnT>
+                    <a:lnB w="6350" cap="flat" cmpd="sng" algn="ctr">
+                      <a:solidFill>
+                        <a:srgbClr val="E5E2DC"/>
+                      </a:solidFill>
+                      <a:prstDash val="solid"/>
+                      <a:round/>
+                      <a:headEnd type="none" w="med" len="med"/>
+                      <a:tailEnd type="none" w="med" len="med"/>
+                    </a:lnB>
+                  </a:tcPr>
+                </a:tc>
+                <a:tc>
+                  <a:txBody>
+                    <a:bodyPr/>
+                    <a:lstStyle/>
+                    <a:p>
+                      <a:pPr indent="0" marL="0">
+                        <a:buNone/>
+                      </a:pPr>
+                      <a:r>
+                        <a:rPr lang="en-US" sz="1300" dirty="0">
+                          <a:solidFill>
+                            <a:srgbClr val="3D3A36"/>
+                          </a:solidFill>
+                          <a:latin typeface="Calibri" pitchFamily="34" charset="0"/>
+                          <a:ea typeface="Calibri" pitchFamily="34" charset="-122"/>
+                          <a:cs typeface="Calibri" pitchFamily="34" charset="-120"/>
+                        </a:rPr>
+                        <a:t>1 L</a:t>
+                      </a:r>
+                      <a:endParaRPr lang="en-US" sz="1300" dirty="0">
+                        <a:latin typeface="Calibri" charset="0"/>
+                        <a:ea typeface="Calibri" charset="0"/>
+                        <a:cs typeface="Calibri" charset="0"/>
+                      </a:endParaRPr>
+                    </a:p>
+                  </a:txBody>
+                  <a:tcPr marL="91440" marR="91440" marT="45720" marB="45720">
+                    <a:lnL w="6350" cap="flat" cmpd="sng" algn="ctr">
+                      <a:solidFill>
+                        <a:srgbClr val="E5E2DC"/>
+                      </a:solidFill>
+                      <a:prstDash val="solid"/>
+                      <a:round/>
+                      <a:headEnd type="none" w="med" len="med"/>
+                      <a:tailEnd type="none" w="med" len="med"/>
+                    </a:lnL>
+                    <a:lnR w="6350" cap="flat" cmpd="sng" algn="ctr">
+                      <a:solidFill>
+                        <a:srgbClr val="E5E2DC"/>
+                      </a:solidFill>
+                      <a:prstDash val="solid"/>
+                      <a:round/>
+                      <a:headEnd type="none" w="med" len="med"/>
+                      <a:tailEnd type="none" w="med" len="med"/>
+                    </a:lnR>
+                    <a:lnT w="6350" cap="flat" cmpd="sng" algn="ctr">
+                      <a:solidFill>
+                        <a:srgbClr val="E5E2DC"/>
+                      </a:solidFill>
+                      <a:prstDash val="solid"/>
+                      <a:round/>
+                      <a:headEnd type="none" w="med" len="med"/>
+                      <a:tailEnd type="none" w="med" len="med"/>
+                    </a:lnT>
+                    <a:lnB w="6350" cap="flat" cmpd="sng" algn="ctr">
+                      <a:solidFill>
+                        <a:srgbClr val="E5E2DC"/>
+                      </a:solidFill>
+                      <a:prstDash val="solid"/>
+                      <a:round/>
+                      <a:headEnd type="none" w="med" len="med"/>
+                      <a:tailEnd type="none" w="med" len="med"/>
+                    </a:lnB>
+                  </a:tcPr>
+                </a:tc>
+                <a:tc>
+                  <a:txBody>
+                    <a:bodyPr/>
+                    <a:lstStyle/>
+                    <a:p>
+                      <a:pPr indent="0" marL="0">
+                        <a:buNone/>
+                      </a:pPr>
+                      <a:r>
+                        <a:rPr lang="en-US" sz="1300" dirty="0">
+                          <a:solidFill>
+                            <a:srgbClr val="3D3A36"/>
+                          </a:solidFill>
+                          <a:latin typeface="Calibri" pitchFamily="34" charset="0"/>
+                          <a:ea typeface="Calibri" pitchFamily="34" charset="-122"/>
+                          <a:cs typeface="Calibri" pitchFamily="34" charset="-120"/>
+                        </a:rPr>
+                        <a:t>Divide cm³ by 1,000</a:t>
+                      </a:r>
+                      <a:endParaRPr lang="en-US" sz="1300" dirty="0">
+                        <a:latin typeface="Calibri" charset="0"/>
+                        <a:ea typeface="Calibri" charset="0"/>
+                        <a:cs typeface="Calibri" charset="0"/>
+                      </a:endParaRPr>
+                    </a:p>
+                  </a:txBody>
+                  <a:tcPr marL="91440" marR="91440" marT="45720" marB="45720">
+                    <a:lnL w="6350" cap="flat" cmpd="sng" algn="ctr">
+                      <a:solidFill>
+                        <a:srgbClr val="E5E2DC"/>
+                      </a:solidFill>
+                      <a:prstDash val="solid"/>
+                      <a:round/>
+                      <a:headEnd type="none" w="med" len="med"/>
+                      <a:tailEnd type="none" w="med" len="med"/>
+                    </a:lnL>
+                    <a:lnR w="6350" cap="flat" cmpd="sng" algn="ctr">
+                      <a:solidFill>
+                        <a:srgbClr val="E5E2DC"/>
+                      </a:solidFill>
+                      <a:prstDash val="solid"/>
+                      <a:round/>
+                      <a:headEnd type="none" w="med" len="med"/>
+                      <a:tailEnd type="none" w="med" len="med"/>
+                    </a:lnR>
+                    <a:lnT w="6350" cap="flat" cmpd="sng" algn="ctr">
+                      <a:solidFill>
+                        <a:srgbClr val="E5E2DC"/>
+                      </a:solidFill>
+                      <a:prstDash val="solid"/>
+                      <a:round/>
+                      <a:headEnd type="none" w="med" len="med"/>
+                      <a:tailEnd type="none" w="med" len="med"/>
+                    </a:lnT>
+                    <a:lnB w="6350" cap="flat" cmpd="sng" algn="ctr">
+                      <a:solidFill>
+                        <a:srgbClr val="E5E2DC"/>
+                      </a:solidFill>
+                      <a:prstDash val="solid"/>
+                      <a:round/>
+                      <a:headEnd type="none" w="med" len="med"/>
+                      <a:tailEnd type="none" w="med" len="med"/>
+                    </a:lnB>
+                  </a:tcPr>
+                </a:tc>
+              </a:tr>
+              <a:tr h="502920">
+                <a:tc>
+                  <a:txBody>
+                    <a:bodyPr/>
+                    <a:lstStyle/>
+                    <a:p>
+                      <a:pPr indent="0" marL="0">
+                        <a:buNone/>
+                      </a:pPr>
+                      <a:r>
+                        <a:rPr lang="en-US" sz="1300" dirty="0">
+                          <a:solidFill>
+                            <a:srgbClr val="3D3A36"/>
+                          </a:solidFill>
+                          <a:latin typeface="Calibri" pitchFamily="34" charset="0"/>
+                          <a:ea typeface="Calibri" pitchFamily="34" charset="-122"/>
+                          <a:cs typeface="Calibri" pitchFamily="34" charset="-120"/>
+                        </a:rPr>
+                        <a:t>1 m³</a:t>
+                      </a:r>
+                      <a:endParaRPr lang="en-US" sz="1300" dirty="0">
+                        <a:latin typeface="Calibri" charset="0"/>
+                        <a:ea typeface="Calibri" charset="0"/>
+                        <a:cs typeface="Calibri" charset="0"/>
+                      </a:endParaRPr>
+                    </a:p>
+                  </a:txBody>
+                  <a:tcPr marL="91440" marR="91440" marT="45720" marB="45720">
+                    <a:lnL w="6350" cap="flat" cmpd="sng" algn="ctr">
+                      <a:solidFill>
+                        <a:srgbClr val="E5E2DC"/>
+                      </a:solidFill>
+                      <a:prstDash val="solid"/>
+                      <a:round/>
+                      <a:headEnd type="none" w="med" len="med"/>
+                      <a:tailEnd type="none" w="med" len="med"/>
+                    </a:lnL>
+                    <a:lnR w="6350" cap="flat" cmpd="sng" algn="ctr">
+                      <a:solidFill>
+                        <a:srgbClr val="E5E2DC"/>
+                      </a:solidFill>
+                      <a:prstDash val="solid"/>
+                      <a:round/>
+                      <a:headEnd type="none" w="med" len="med"/>
+                      <a:tailEnd type="none" w="med" len="med"/>
+                    </a:lnR>
+                    <a:lnT w="6350" cap="flat" cmpd="sng" algn="ctr">
+                      <a:solidFill>
+                        <a:srgbClr val="E5E2DC"/>
+                      </a:solidFill>
+                      <a:prstDash val="solid"/>
+                      <a:round/>
+                      <a:headEnd type="none" w="med" len="med"/>
+                      <a:tailEnd type="none" w="med" len="med"/>
+                    </a:lnT>
+                    <a:lnB w="6350" cap="flat" cmpd="sng" algn="ctr">
+                      <a:solidFill>
+                        <a:srgbClr val="E5E2DC"/>
+                      </a:solidFill>
+                      <a:prstDash val="solid"/>
+                      <a:round/>
+                      <a:headEnd type="none" w="med" len="med"/>
+                      <a:tailEnd type="none" w="med" len="med"/>
+                    </a:lnB>
+                  </a:tcPr>
+                </a:tc>
+                <a:tc>
+                  <a:txBody>
+                    <a:bodyPr/>
+                    <a:lstStyle/>
+                    <a:p>
+                      <a:pPr indent="0" marL="0">
+                        <a:buNone/>
+                      </a:pPr>
+                      <a:r>
+                        <a:rPr lang="en-US" sz="1300" dirty="0">
+                          <a:solidFill>
+                            <a:srgbClr val="3D3A36"/>
+                          </a:solidFill>
+                          <a:latin typeface="Calibri" pitchFamily="34" charset="0"/>
+                          <a:ea typeface="Calibri" pitchFamily="34" charset="-122"/>
+                          <a:cs typeface="Calibri" pitchFamily="34" charset="-120"/>
+                        </a:rPr>
+                        <a:t>1,000 L</a:t>
+                      </a:r>
+                      <a:endParaRPr lang="en-US" sz="1300" dirty="0">
+                        <a:latin typeface="Calibri" charset="0"/>
+                        <a:ea typeface="Calibri" charset="0"/>
+                        <a:cs typeface="Calibri" charset="0"/>
+                      </a:endParaRPr>
+                    </a:p>
+                  </a:txBody>
+                  <a:tcPr marL="91440" marR="91440" marT="45720" marB="45720">
+                    <a:lnL w="6350" cap="flat" cmpd="sng" algn="ctr">
+                      <a:solidFill>
+                        <a:srgbClr val="E5E2DC"/>
+                      </a:solidFill>
+                      <a:prstDash val="solid"/>
+                      <a:round/>
+                      <a:headEnd type="none" w="med" len="med"/>
+                      <a:tailEnd type="none" w="med" len="med"/>
+                    </a:lnL>
+                    <a:lnR w="6350" cap="flat" cmpd="sng" algn="ctr">
+                      <a:solidFill>
+                        <a:srgbClr val="E5E2DC"/>
+                      </a:solidFill>
+                      <a:prstDash val="solid"/>
+                      <a:round/>
+                      <a:headEnd type="none" w="med" len="med"/>
+                      <a:tailEnd type="none" w="med" len="med"/>
+                    </a:lnR>
+                    <a:lnT w="6350" cap="flat" cmpd="sng" algn="ctr">
+                      <a:solidFill>
+                        <a:srgbClr val="E5E2DC"/>
+                      </a:solidFill>
+                      <a:prstDash val="solid"/>
+                      <a:round/>
+                      <a:headEnd type="none" w="med" len="med"/>
+                      <a:tailEnd type="none" w="med" len="med"/>
+                    </a:lnT>
+                    <a:lnB w="6350" cap="flat" cmpd="sng" algn="ctr">
+                      <a:solidFill>
+                        <a:srgbClr val="E5E2DC"/>
+                      </a:solidFill>
+                      <a:prstDash val="solid"/>
+                      <a:round/>
+                      <a:headEnd type="none" w="med" len="med"/>
+                      <a:tailEnd type="none" w="med" len="med"/>
+                    </a:lnB>
+                  </a:tcPr>
+                </a:tc>
+                <a:tc>
+                  <a:txBody>
+                    <a:bodyPr/>
+                    <a:lstStyle/>
+                    <a:p>
+                      <a:pPr indent="0" marL="0">
+                        <a:buNone/>
+                      </a:pPr>
+                      <a:r>
+                        <a:rPr lang="en-US" sz="1300" dirty="0">
+                          <a:solidFill>
+                            <a:srgbClr val="3D3A36"/>
+                          </a:solidFill>
+                          <a:latin typeface="Calibri" pitchFamily="34" charset="0"/>
+                          <a:ea typeface="Calibri" pitchFamily="34" charset="-122"/>
+                          <a:cs typeface="Calibri" pitchFamily="34" charset="-120"/>
+                        </a:rPr>
+                        <a:t>1 cubic metre = 1,000 litres</a:t>
+                      </a:r>
+                      <a:endParaRPr lang="en-US" sz="1300" dirty="0">
+                        <a:latin typeface="Calibri" charset="0"/>
+                        <a:ea typeface="Calibri" charset="0"/>
+                        <a:cs typeface="Calibri" charset="0"/>
+                      </a:endParaRPr>
+                    </a:p>
+                  </a:txBody>
+                  <a:tcPr marL="91440" marR="91440" marT="45720" marB="45720">
+                    <a:lnL w="6350" cap="flat" cmpd="sng" algn="ctr">
+                      <a:solidFill>
+                        <a:srgbClr val="E5E2DC"/>
+                      </a:solidFill>
+                      <a:prstDash val="solid"/>
+                      <a:round/>
+                      <a:headEnd type="none" w="med" len="med"/>
+                      <a:tailEnd type="none" w="med" len="med"/>
+                    </a:lnL>
+                    <a:lnR w="6350" cap="flat" cmpd="sng" algn="ctr">
+                      <a:solidFill>
+                        <a:srgbClr val="E5E2DC"/>
+                      </a:solidFill>
+                      <a:prstDash val="solid"/>
+                      <a:round/>
+                      <a:headEnd type="none" w="med" len="med"/>
+                      <a:tailEnd type="none" w="med" len="med"/>
+                    </a:lnR>
+                    <a:lnT w="6350" cap="flat" cmpd="sng" algn="ctr">
+                      <a:solidFill>
+                        <a:srgbClr val="E5E2DC"/>
+                      </a:solidFill>
+                      <a:prstDash val="solid"/>
+                      <a:round/>
+                      <a:headEnd type="none" w="med" len="med"/>
+                      <a:tailEnd type="none" w="med" len="med"/>
+                    </a:lnT>
+                    <a:lnB w="6350" cap="flat" cmpd="sng" algn="ctr">
+                      <a:solidFill>
+                        <a:srgbClr val="E5E2DC"/>
+                      </a:solidFill>
+                      <a:prstDash val="solid"/>
+                      <a:round/>
+                      <a:headEnd type="none" w="med" len="med"/>
+                      <a:tailEnd type="none" w="med" len="med"/>
+                    </a:lnB>
+                  </a:tcPr>
+                </a:tc>
+              </a:tr>
+              <a:tr h="502920">
+                <a:tc>
+                  <a:txBody>
+                    <a:bodyPr/>
+                    <a:lstStyle/>
+                    <a:p>
+                      <a:pPr indent="0" marL="0">
+                        <a:buNone/>
+                      </a:pPr>
+                      <a:r>
+                        <a:rPr lang="en-US" sz="1300" dirty="0">
+                          <a:solidFill>
+                            <a:srgbClr val="3D3A36"/>
+                          </a:solidFill>
+                          <a:latin typeface="Calibri" pitchFamily="34" charset="0"/>
+                          <a:ea typeface="Calibri" pitchFamily="34" charset="-122"/>
+                          <a:cs typeface="Calibri" pitchFamily="34" charset="-120"/>
+                        </a:rPr>
+                        <a:t>1,000 mL</a:t>
+                      </a:r>
+                      <a:endParaRPr lang="en-US" sz="1300" dirty="0">
+                        <a:latin typeface="Calibri" charset="0"/>
+                        <a:ea typeface="Calibri" charset="0"/>
+                        <a:cs typeface="Calibri" charset="0"/>
+                      </a:endParaRPr>
+                    </a:p>
+                  </a:txBody>
+                  <a:tcPr marL="91440" marR="91440" marT="45720" marB="45720">
+                    <a:lnL w="6350" cap="flat" cmpd="sng" algn="ctr">
+                      <a:solidFill>
+                        <a:srgbClr val="E5E2DC"/>
+                      </a:solidFill>
+                      <a:prstDash val="solid"/>
+                      <a:round/>
+                      <a:headEnd type="none" w="med" len="med"/>
+                      <a:tailEnd type="none" w="med" len="med"/>
+                    </a:lnL>
+                    <a:lnR w="6350" cap="flat" cmpd="sng" algn="ctr">
+                      <a:solidFill>
+                        <a:srgbClr val="E5E2DC"/>
+                      </a:solidFill>
+                      <a:prstDash val="solid"/>
+                      <a:round/>
+                      <a:headEnd type="none" w="med" len="med"/>
+                      <a:tailEnd type="none" w="med" len="med"/>
+                    </a:lnR>
+                    <a:lnT w="6350" cap="flat" cmpd="sng" algn="ctr">
+                      <a:solidFill>
+                        <a:srgbClr val="E5E2DC"/>
+                      </a:solidFill>
+                      <a:prstDash val="solid"/>
+                      <a:round/>
+                      <a:headEnd type="none" w="med" len="med"/>
+                      <a:tailEnd type="none" w="med" len="med"/>
+                    </a:lnT>
+                    <a:lnB w="6350" cap="flat" cmpd="sng" algn="ctr">
+                      <a:solidFill>
+                        <a:srgbClr val="E5E2DC"/>
+                      </a:solidFill>
+                      <a:prstDash val="solid"/>
+                      <a:round/>
+                      <a:headEnd type="none" w="med" len="med"/>
+                      <a:tailEnd type="none" w="med" len="med"/>
+                    </a:lnB>
+                  </a:tcPr>
+                </a:tc>
+                <a:tc>
+                  <a:txBody>
+                    <a:bodyPr/>
+                    <a:lstStyle/>
+                    <a:p>
+                      <a:pPr indent="0" marL="0">
+                        <a:buNone/>
+                      </a:pPr>
+                      <a:r>
+                        <a:rPr lang="en-US" sz="1300" dirty="0">
+                          <a:solidFill>
+                            <a:srgbClr val="3D3A36"/>
+                          </a:solidFill>
+                          <a:latin typeface="Calibri" pitchFamily="34" charset="0"/>
+                          <a:ea typeface="Calibri" pitchFamily="34" charset="-122"/>
+                          <a:cs typeface="Calibri" pitchFamily="34" charset="-120"/>
+                        </a:rPr>
+                        <a:t>1 L</a:t>
+                      </a:r>
+                      <a:endParaRPr lang="en-US" sz="1300" dirty="0">
+                        <a:latin typeface="Calibri" charset="0"/>
+                        <a:ea typeface="Calibri" charset="0"/>
+                        <a:cs typeface="Calibri" charset="0"/>
+                      </a:endParaRPr>
+                    </a:p>
+                  </a:txBody>
+                  <a:tcPr marL="91440" marR="91440" marT="45720" marB="45720">
+                    <a:lnL w="6350" cap="flat" cmpd="sng" algn="ctr">
+                      <a:solidFill>
+                        <a:srgbClr val="E5E2DC"/>
+                      </a:solidFill>
+                      <a:prstDash val="solid"/>
+                      <a:round/>
+                      <a:headEnd type="none" w="med" len="med"/>
+                      <a:tailEnd type="none" w="med" len="med"/>
+                    </a:lnL>
+                    <a:lnR w="6350" cap="flat" cmpd="sng" algn="ctr">
+                      <a:solidFill>
+                        <a:srgbClr val="E5E2DC"/>
+                      </a:solidFill>
+                      <a:prstDash val="solid"/>
+                      <a:round/>
+                      <a:headEnd type="none" w="med" len="med"/>
+                      <a:tailEnd type="none" w="med" len="med"/>
+                    </a:lnR>
+                    <a:lnT w="6350" cap="flat" cmpd="sng" algn="ctr">
+                      <a:solidFill>
+                        <a:srgbClr val="E5E2DC"/>
+                      </a:solidFill>
+                      <a:prstDash val="solid"/>
+                      <a:round/>
+                      <a:headEnd type="none" w="med" len="med"/>
+                      <a:tailEnd type="none" w="med" len="med"/>
+                    </a:lnT>
+                    <a:lnB w="6350" cap="flat" cmpd="sng" algn="ctr">
+                      <a:solidFill>
+                        <a:srgbClr val="E5E2DC"/>
+                      </a:solidFill>
+                      <a:prstDash val="solid"/>
+                      <a:round/>
+                      <a:headEnd type="none" w="med" len="med"/>
+                      <a:tailEnd type="none" w="med" len="med"/>
+                    </a:lnB>
+                  </a:tcPr>
+                </a:tc>
+                <a:tc>
+                  <a:txBody>
+                    <a:bodyPr/>
+                    <a:lstStyle/>
+                    <a:p>
+                      <a:pPr indent="0" marL="0">
+                        <a:buNone/>
+                      </a:pPr>
+                      <a:r>
+                        <a:rPr lang="en-US" sz="1300" dirty="0">
+                          <a:solidFill>
+                            <a:srgbClr val="3D3A36"/>
+                          </a:solidFill>
+                          <a:latin typeface="Calibri" pitchFamily="34" charset="0"/>
+                          <a:ea typeface="Calibri" pitchFamily="34" charset="-122"/>
+                          <a:cs typeface="Calibri" pitchFamily="34" charset="-120"/>
+                        </a:rPr>
+                        <a:t>Divide mL by 1,000</a:t>
+                      </a:r>
+                      <a:endParaRPr lang="en-US" sz="1300" dirty="0">
+                        <a:latin typeface="Calibri" charset="0"/>
+                        <a:ea typeface="Calibri" charset="0"/>
+                        <a:cs typeface="Calibri" charset="0"/>
+                      </a:endParaRPr>
+                    </a:p>
+                  </a:txBody>
+                  <a:tcPr marL="91440" marR="91440" marT="45720" marB="45720">
+                    <a:lnL w="6350" cap="flat" cmpd="sng" algn="ctr">
+                      <a:solidFill>
+                        <a:srgbClr val="E5E2DC"/>
+                      </a:solidFill>
+                      <a:prstDash val="solid"/>
+                      <a:round/>
+                      <a:headEnd type="none" w="med" len="med"/>
+                      <a:tailEnd type="none" w="med" len="med"/>
+                    </a:lnL>
+                    <a:lnR w="6350" cap="flat" cmpd="sng" algn="ctr">
+                      <a:solidFill>
+                        <a:srgbClr val="E5E2DC"/>
+                      </a:solidFill>
+                      <a:prstDash val="solid"/>
+                      <a:round/>
+                      <a:headEnd type="none" w="med" len="med"/>
+                      <a:tailEnd type="none" w="med" len="med"/>
+                    </a:lnR>
+                    <a:lnT w="6350" cap="flat" cmpd="sng" algn="ctr">
+                      <a:solidFill>
+                        <a:srgbClr val="E5E2DC"/>
+                      </a:solidFill>
+                      <a:prstDash val="solid"/>
+                      <a:round/>
+                      <a:headEnd type="none" w="med" len="med"/>
+                      <a:tailEnd type="none" w="med" len="med"/>
+                    </a:lnT>
+                    <a:lnB w="6350" cap="flat" cmpd="sng" algn="ctr">
+                      <a:solidFill>
+                        <a:srgbClr val="E5E2DC"/>
+                      </a:solidFill>
+                      <a:prstDash val="solid"/>
+                      <a:round/>
+                      <a:headEnd type="none" w="med" len="med"/>
+                      <a:tailEnd type="none" w="med" len="med"/>
+                    </a:lnB>
+                  </a:tcPr>
+                </a:tc>
+              </a:tr>
+            </a:tbl>
+          </a:graphicData>
+        </a:graphic>
+      </p:graphicFrame>
     </p:spTree>
   </p:cSld>
   <p:clrMapOvr>
@@ -2386,7 +3487,7 @@
     <p:bg>
       <p:bgPr>
         <a:solidFill>
-          <a:srgbClr val="1B2A4A"/>
+          <a:srgbClr val="FAF8F5"/>
         </a:solidFill>
       </p:bgPr>
     </p:bg>
@@ -2413,27 +3514,47 @@
         <p:spPr>
           <a:xfrm>
             <a:off x="0" y="0"/>
-            <a:ext cx="109728" cy="5143500"/>
+            <a:ext cx="9144000" cy="822960"/>
           </a:xfrm>
           <a:prstGeom prst="rect">
             <a:avLst/>
           </a:prstGeom>
           <a:solidFill>
-            <a:srgbClr val="E9C46A"/>
+            <a:srgbClr val="FFFFFF"/>
           </a:solidFill>
           <a:ln/>
         </p:spPr>
       </p:sp>
       <p:sp>
         <p:nvSpPr>
-          <p:cNvPr id="3" name="Text 1"/>
-          <p:cNvSpPr/>
-          <p:nvPr/>
-        </p:nvSpPr>
-        <p:spPr>
-          <a:xfrm>
-            <a:off x="731520" y="457200"/>
-            <a:ext cx="7772400" cy="731520"/>
+          <p:cNvPr id="3" name="Shape 1"/>
+          <p:cNvSpPr/>
+          <p:nvPr/>
+        </p:nvSpPr>
+        <p:spPr>
+          <a:xfrm>
+            <a:off x="0" y="795528"/>
+            <a:ext cx="9144000" cy="27432"/>
+          </a:xfrm>
+          <a:prstGeom prst="rect">
+            <a:avLst/>
+          </a:prstGeom>
+          <a:solidFill>
+            <a:srgbClr val="2A9D8F"/>
+          </a:solidFill>
+          <a:ln/>
+        </p:spPr>
+      </p:sp>
+      <p:sp>
+        <p:nvSpPr>
+          <p:cNvPr id="4" name="Text 2"/>
+          <p:cNvSpPr/>
+          <p:nvPr/>
+        </p:nvSpPr>
+        <p:spPr>
+          <a:xfrm>
+            <a:off x="640080" y="91440"/>
+            <a:ext cx="7863840" cy="640080"/>
           </a:xfrm>
           <a:prstGeom prst="rect">
             <a:avLst/>
@@ -2442,14 +3563,1125 @@
           <a:ln/>
         </p:spPr>
         <p:txBody>
-          <a:bodyPr wrap="square" rtlCol="0" anchor="ctr"/>
+          <a:bodyPr wrap="square" lIns="0" tIns="0" rIns="0" bIns="0" rtlCol="0" anchor="ctr"/>
           <a:lstStyle/>
           <a:p>
             <a:pPr indent="0" marL="0">
               <a:buNone/>
             </a:pPr>
             <a:r>
-              <a:rPr lang="en-US" sz="3200" b="1" dirty="0">
+              <a:rPr lang="en-US" sz="2200" b="1" dirty="0">
+                <a:solidFill>
+                  <a:srgbClr val="1B2A4A"/>
+                </a:solidFill>
+                <a:latin typeface="Georgia" pitchFamily="34" charset="0"/>
+                <a:ea typeface="Georgia" pitchFamily="34" charset="-122"/>
+                <a:cs typeface="Georgia" pitchFamily="34" charset="-120"/>
+              </a:rPr>
+              <a:t>NIS Pool — Capacity</a:t>
+            </a:r>
+            <a:endParaRPr lang="en-US" sz="2200" dirty="0"/>
+          </a:p>
+        </p:txBody>
+      </p:sp>
+      <p:sp>
+        <p:nvSpPr>
+          <p:cNvPr id="5" name="Text 3"/>
+          <p:cNvSpPr/>
+          <p:nvPr/>
+        </p:nvSpPr>
+        <p:spPr>
+          <a:xfrm>
+            <a:off x="640080" y="1005840"/>
+            <a:ext cx="7863840" cy="2926080"/>
+          </a:xfrm>
+          <a:prstGeom prst="rect">
+            <a:avLst/>
+          </a:prstGeom>
+          <a:noFill/>
+          <a:ln/>
+        </p:spPr>
+        <p:txBody>
+          <a:bodyPr wrap="square" rtlCol="0" anchor="ctr"/>
+          <a:lstStyle/>
+          <a:p>
+            <a:pPr marL="342900" indent="-342900">
+              <a:spcAft>
+                <a:spcPts val="800"/>
+              </a:spcAft>
+              <a:buSzPct val="100000"/>
+              <a:buChar char="•"/>
+            </a:pPr>
+            <a:r>
+              <a:rPr lang="en-US" sz="1600" dirty="0">
+                <a:solidFill>
+                  <a:srgbClr val="3D3A36"/>
+                </a:solidFill>
+                <a:latin typeface="Calibri" pitchFamily="34" charset="0"/>
+                <a:ea typeface="Calibri" pitchFamily="34" charset="-122"/>
+                <a:cs typeface="Calibri" pitchFamily="34" charset="-120"/>
+              </a:rPr>
+              <a:t>Pool volume = 640 m³.</a:t>
+            </a:r>
+            <a:endParaRPr lang="en-US" sz="1600" dirty="0"/>
+          </a:p>
+          <a:p>
+            <a:pPr marL="342900" indent="-342900">
+              <a:spcAft>
+                <a:spcPts val="800"/>
+              </a:spcAft>
+              <a:buSzPct val="100000"/>
+              <a:buChar char="•"/>
+            </a:pPr>
+            <a:r>
+              <a:rPr lang="en-US" sz="1600" dirty="0">
+                <a:solidFill>
+                  <a:srgbClr val="3D3A36"/>
+                </a:solidFill>
+                <a:latin typeface="Calibri" pitchFamily="34" charset="0"/>
+                <a:ea typeface="Calibri" pitchFamily="34" charset="-122"/>
+                <a:cs typeface="Calibri" pitchFamily="34" charset="-120"/>
+              </a:rPr>
+              <a:t>1 m³ = 1,000 L</a:t>
+            </a:r>
+            <a:endParaRPr lang="en-US" sz="1600" dirty="0"/>
+          </a:p>
+          <a:p>
+            <a:pPr marL="342900" indent="-342900">
+              <a:spcAft>
+                <a:spcPts val="800"/>
+              </a:spcAft>
+              <a:buSzPct val="100000"/>
+              <a:buChar char="•"/>
+            </a:pPr>
+            <a:r>
+              <a:rPr lang="en-US" sz="1600" dirty="0">
+                <a:solidFill>
+                  <a:srgbClr val="3D3A36"/>
+                </a:solidFill>
+                <a:latin typeface="Calibri" pitchFamily="34" charset="0"/>
+                <a:ea typeface="Calibri" pitchFamily="34" charset="-122"/>
+                <a:cs typeface="Calibri" pitchFamily="34" charset="-120"/>
+              </a:rPr>
+              <a:t>640 × 1,000 = 640,000 litres!</a:t>
+            </a:r>
+            <a:endParaRPr lang="en-US" sz="1600" dirty="0"/>
+          </a:p>
+          <a:p>
+            <a:pPr marL="342900" indent="-342900">
+              <a:spcAft>
+                <a:spcPts val="800"/>
+              </a:spcAft>
+              <a:buSzPct val="100000"/>
+              <a:buChar char="•"/>
+            </a:pPr>
+            <a:r>
+              <a:rPr lang="en-US" sz="1600" dirty="0">
+                <a:solidFill>
+                  <a:srgbClr val="3D3A36"/>
+                </a:solidFill>
+                <a:latin typeface="Calibri" pitchFamily="34" charset="0"/>
+                <a:ea typeface="Calibri" pitchFamily="34" charset="-122"/>
+                <a:cs typeface="Calibri" pitchFamily="34" charset="-120"/>
+              </a:rPr>
+              <a:t>That's about 1,778 Korean soju bottles... just kidding.</a:t>
+            </a:r>
+            <a:endParaRPr lang="en-US" sz="1600" dirty="0"/>
+          </a:p>
+          <a:p>
+            <a:pPr marL="342900" indent="-342900">
+              <a:spcAft>
+                <a:spcPts val="800"/>
+              </a:spcAft>
+              <a:buSzPct val="100000"/>
+              <a:buChar char="•"/>
+            </a:pPr>
+            <a:r>
+              <a:rPr lang="en-US" sz="1600" dirty="0">
+                <a:solidFill>
+                  <a:srgbClr val="3D3A36"/>
+                </a:solidFill>
+                <a:latin typeface="Calibri" pitchFamily="34" charset="0"/>
+                <a:ea typeface="Calibri" pitchFamily="34" charset="-122"/>
+                <a:cs typeface="Calibri" pitchFamily="34" charset="-120"/>
+              </a:rPr>
+              <a:t>Or about 2,133 bathtubs full of water.</a:t>
+            </a:r>
+            <a:endParaRPr lang="en-US" sz="1600" dirty="0"/>
+          </a:p>
+        </p:txBody>
+      </p:sp>
+    </p:spTree>
+  </p:cSld>
+  <p:clrMapOvr>
+    <a:masterClrMapping/>
+  </p:clrMapOvr>
+</p:sld>
+</file>
+
+<file path=ppt/slides/slide6.xml><?xml version="1.0" encoding="utf-8"?>
+<p:sld xmlns:a="http://schemas.openxmlformats.org/drawingml/2006/main" xmlns:r="http://schemas.openxmlformats.org/officeDocument/2006/relationships" xmlns:p="http://schemas.openxmlformats.org/presentationml/2006/main">
+  <p:cSld name="Slide 6">
+    <p:bg>
+      <p:bgPr>
+        <a:solidFill>
+          <a:srgbClr val="FAF8F5"/>
+        </a:solidFill>
+      </p:bgPr>
+    </p:bg>
+    <p:spTree>
+      <p:nvGrpSpPr>
+        <p:cNvPr id="1" name=""/>
+        <p:cNvGrpSpPr/>
+        <p:nvPr/>
+      </p:nvGrpSpPr>
+      <p:grpSpPr>
+        <a:xfrm>
+          <a:off x="0" y="0"/>
+          <a:ext cx="0" cy="0"/>
+          <a:chOff x="0" y="0"/>
+          <a:chExt cx="0" cy="0"/>
+        </a:xfrm>
+      </p:grpSpPr>
+      <p:sp>
+        <p:nvSpPr>
+          <p:cNvPr id="2" name="Shape 0"/>
+          <p:cNvSpPr/>
+          <p:nvPr/>
+        </p:nvSpPr>
+        <p:spPr>
+          <a:xfrm>
+            <a:off x="0" y="0"/>
+            <a:ext cx="9144000" cy="822960"/>
+          </a:xfrm>
+          <a:prstGeom prst="rect">
+            <a:avLst/>
+          </a:prstGeom>
+          <a:solidFill>
+            <a:srgbClr val="FFFFFF"/>
+          </a:solidFill>
+          <a:ln/>
+        </p:spPr>
+      </p:sp>
+      <p:sp>
+        <p:nvSpPr>
+          <p:cNvPr id="3" name="Shape 1"/>
+          <p:cNvSpPr/>
+          <p:nvPr/>
+        </p:nvSpPr>
+        <p:spPr>
+          <a:xfrm>
+            <a:off x="0" y="795528"/>
+            <a:ext cx="9144000" cy="27432"/>
+          </a:xfrm>
+          <a:prstGeom prst="rect">
+            <a:avLst/>
+          </a:prstGeom>
+          <a:solidFill>
+            <a:srgbClr val="2A9D8F"/>
+          </a:solidFill>
+          <a:ln/>
+        </p:spPr>
+      </p:sp>
+      <p:sp>
+        <p:nvSpPr>
+          <p:cNvPr id="4" name="Text 2"/>
+          <p:cNvSpPr/>
+          <p:nvPr/>
+        </p:nvSpPr>
+        <p:spPr>
+          <a:xfrm>
+            <a:off x="640080" y="91440"/>
+            <a:ext cx="7863840" cy="640080"/>
+          </a:xfrm>
+          <a:prstGeom prst="rect">
+            <a:avLst/>
+          </a:prstGeom>
+          <a:noFill/>
+          <a:ln/>
+        </p:spPr>
+        <p:txBody>
+          <a:bodyPr wrap="square" lIns="0" tIns="0" rIns="0" bIns="0" rtlCol="0" anchor="ctr"/>
+          <a:lstStyle/>
+          <a:p>
+            <a:pPr indent="0" marL="0">
+              <a:buNone/>
+            </a:pPr>
+            <a:r>
+              <a:rPr lang="en-US" sz="2200" b="1" dirty="0">
+                <a:solidFill>
+                  <a:srgbClr val="1B2A4A"/>
+                </a:solidFill>
+                <a:latin typeface="Georgia" pitchFamily="34" charset="0"/>
+                <a:ea typeface="Georgia" pitchFamily="34" charset="-122"/>
+                <a:cs typeface="Georgia" pitchFamily="34" charset="-120"/>
+              </a:rPr>
+              <a:t>Real-World Capacity</a:t>
+            </a:r>
+            <a:endParaRPr lang="en-US" sz="2200" dirty="0"/>
+          </a:p>
+        </p:txBody>
+      </p:sp>
+      <p:sp>
+        <p:nvSpPr>
+          <p:cNvPr id="5" name="Text 3"/>
+          <p:cNvSpPr/>
+          <p:nvPr/>
+        </p:nvSpPr>
+        <p:spPr>
+          <a:xfrm>
+            <a:off x="640080" y="1005840"/>
+            <a:ext cx="7863840" cy="2926080"/>
+          </a:xfrm>
+          <a:prstGeom prst="rect">
+            <a:avLst/>
+          </a:prstGeom>
+          <a:noFill/>
+          <a:ln/>
+        </p:spPr>
+        <p:txBody>
+          <a:bodyPr wrap="square" rtlCol="0" anchor="ctr"/>
+          <a:lstStyle/>
+          <a:p>
+            <a:pPr marL="342900" indent="-342900">
+              <a:spcAft>
+                <a:spcPts val="800"/>
+              </a:spcAft>
+              <a:buSzPct val="100000"/>
+              <a:buChar char="•"/>
+            </a:pPr>
+            <a:r>
+              <a:rPr lang="en-US" sz="1600" dirty="0">
+                <a:solidFill>
+                  <a:srgbClr val="3D3A36"/>
+                </a:solidFill>
+                <a:latin typeface="Calibri" pitchFamily="34" charset="0"/>
+                <a:ea typeface="Calibri" pitchFamily="34" charset="-122"/>
+                <a:cs typeface="Calibri" pitchFamily="34" charset="-120"/>
+              </a:rPr>
+              <a:t>Chinese tea cup (茶杯): ~150 mL.</a:t>
+            </a:r>
+            <a:endParaRPr lang="en-US" sz="1600" dirty="0"/>
+          </a:p>
+          <a:p>
+            <a:pPr marL="342900" indent="-342900">
+              <a:spcAft>
+                <a:spcPts val="800"/>
+              </a:spcAft>
+              <a:buSzPct val="100000"/>
+              <a:buChar char="•"/>
+            </a:pPr>
+            <a:r>
+              <a:rPr lang="en-US" sz="1600" dirty="0">
+                <a:solidFill>
+                  <a:srgbClr val="3D3A36"/>
+                </a:solidFill>
+                <a:latin typeface="Calibri" pitchFamily="34" charset="0"/>
+                <a:ea typeface="Calibri" pitchFamily="34" charset="-122"/>
+                <a:cs typeface="Calibri" pitchFamily="34" charset="-120"/>
+              </a:rPr>
+              <a:t>Korean soju bottle: 360 mL.</a:t>
+            </a:r>
+            <a:endParaRPr lang="en-US" sz="1600" dirty="0"/>
+          </a:p>
+          <a:p>
+            <a:pPr marL="342900" indent="-342900">
+              <a:spcAft>
+                <a:spcPts val="800"/>
+              </a:spcAft>
+              <a:buSzPct val="100000"/>
+              <a:buChar char="•"/>
+            </a:pPr>
+            <a:r>
+              <a:rPr lang="en-US" sz="1600" dirty="0">
+                <a:solidFill>
+                  <a:srgbClr val="3D3A36"/>
+                </a:solidFill>
+                <a:latin typeface="Calibri" pitchFamily="34" charset="0"/>
+                <a:ea typeface="Calibri" pitchFamily="34" charset="-122"/>
+                <a:cs typeface="Calibri" pitchFamily="34" charset="-120"/>
+              </a:rPr>
+              <a:t>German beer Maß: 1,000 mL (1 L).</a:t>
+            </a:r>
+            <a:endParaRPr lang="en-US" sz="1600" dirty="0"/>
+          </a:p>
+          <a:p>
+            <a:pPr marL="342900" indent="-342900">
+              <a:spcAft>
+                <a:spcPts val="800"/>
+              </a:spcAft>
+              <a:buSzPct val="100000"/>
+              <a:buChar char="•"/>
+            </a:pPr>
+            <a:r>
+              <a:rPr lang="en-US" sz="1600" dirty="0">
+                <a:solidFill>
+                  <a:srgbClr val="3D3A36"/>
+                </a:solidFill>
+                <a:latin typeface="Calibri" pitchFamily="34" charset="0"/>
+                <a:ea typeface="Calibri" pitchFamily="34" charset="-122"/>
+                <a:cs typeface="Calibri" pitchFamily="34" charset="-120"/>
+              </a:rPr>
+              <a:t>Nanjing Xuanwu Lake: ~3.7 million m³ of water.</a:t>
+            </a:r>
+            <a:endParaRPr lang="en-US" sz="1600" dirty="0"/>
+          </a:p>
+          <a:p>
+            <a:pPr marL="342900" indent="-342900">
+              <a:spcAft>
+                <a:spcPts val="800"/>
+              </a:spcAft>
+              <a:buSzPct val="100000"/>
+              <a:buChar char="•"/>
+            </a:pPr>
+            <a:r>
+              <a:rPr lang="en-US" sz="1600" dirty="0">
+                <a:solidFill>
+                  <a:srgbClr val="3D3A36"/>
+                </a:solidFill>
+                <a:latin typeface="Calibri" pitchFamily="34" charset="0"/>
+                <a:ea typeface="Calibri" pitchFamily="34" charset="-122"/>
+                <a:cs typeface="Calibri" pitchFamily="34" charset="-120"/>
+              </a:rPr>
+              <a:t>Always check: does my answer make sense?</a:t>
+            </a:r>
+            <a:endParaRPr lang="en-US" sz="1600" dirty="0"/>
+          </a:p>
+        </p:txBody>
+      </p:sp>
+    </p:spTree>
+  </p:cSld>
+  <p:clrMapOvr>
+    <a:masterClrMapping/>
+  </p:clrMapOvr>
+</p:sld>
+</file>
+
+<file path=ppt/slides/slide7.xml><?xml version="1.0" encoding="utf-8"?>
+<p:sld xmlns:a="http://schemas.openxmlformats.org/drawingml/2006/main" xmlns:r="http://schemas.openxmlformats.org/officeDocument/2006/relationships" xmlns:p="http://schemas.openxmlformats.org/presentationml/2006/main">
+  <p:cSld name="Slide 7">
+    <p:bg>
+      <p:bgPr>
+        <a:solidFill>
+          <a:srgbClr val="FAF8F5"/>
+        </a:solidFill>
+      </p:bgPr>
+    </p:bg>
+    <p:spTree>
+      <p:nvGrpSpPr>
+        <p:cNvPr id="1" name=""/>
+        <p:cNvGrpSpPr/>
+        <p:nvPr/>
+      </p:nvGrpSpPr>
+      <p:grpSpPr>
+        <a:xfrm>
+          <a:off x="0" y="0"/>
+          <a:ext cx="0" cy="0"/>
+          <a:chOff x="0" y="0"/>
+          <a:chExt cx="0" cy="0"/>
+        </a:xfrm>
+      </p:grpSpPr>
+      <p:sp>
+        <p:nvSpPr>
+          <p:cNvPr id="2" name="Shape 0"/>
+          <p:cNvSpPr/>
+          <p:nvPr/>
+        </p:nvSpPr>
+        <p:spPr>
+          <a:xfrm>
+            <a:off x="0" y="0"/>
+            <a:ext cx="9144000" cy="822960"/>
+          </a:xfrm>
+          <a:prstGeom prst="rect">
+            <a:avLst/>
+          </a:prstGeom>
+          <a:solidFill>
+            <a:srgbClr val="FFFFFF"/>
+          </a:solidFill>
+          <a:ln/>
+        </p:spPr>
+      </p:sp>
+      <p:sp>
+        <p:nvSpPr>
+          <p:cNvPr id="3" name="Shape 1"/>
+          <p:cNvSpPr/>
+          <p:nvPr/>
+        </p:nvSpPr>
+        <p:spPr>
+          <a:xfrm>
+            <a:off x="0" y="795528"/>
+            <a:ext cx="9144000" cy="27432"/>
+          </a:xfrm>
+          <a:prstGeom prst="rect">
+            <a:avLst/>
+          </a:prstGeom>
+          <a:solidFill>
+            <a:srgbClr val="2A9D8F"/>
+          </a:solidFill>
+          <a:ln/>
+        </p:spPr>
+      </p:sp>
+      <p:sp>
+        <p:nvSpPr>
+          <p:cNvPr id="4" name="Text 2"/>
+          <p:cNvSpPr/>
+          <p:nvPr/>
+        </p:nvSpPr>
+        <p:spPr>
+          <a:xfrm>
+            <a:off x="640080" y="91440"/>
+            <a:ext cx="7863840" cy="640080"/>
+          </a:xfrm>
+          <a:prstGeom prst="rect">
+            <a:avLst/>
+          </a:prstGeom>
+          <a:noFill/>
+          <a:ln/>
+        </p:spPr>
+        <p:txBody>
+          <a:bodyPr wrap="square" lIns="0" tIns="0" rIns="0" bIns="0" rtlCol="0" anchor="ctr"/>
+          <a:lstStyle/>
+          <a:p>
+            <a:pPr indent="0" marL="0">
+              <a:buNone/>
+            </a:pPr>
+            <a:r>
+              <a:rPr lang="en-US" sz="2200" b="1" dirty="0">
+                <a:solidFill>
+                  <a:srgbClr val="1B2A4A"/>
+                </a:solidFill>
+                <a:latin typeface="Georgia" pitchFamily="34" charset="0"/>
+                <a:ea typeface="Georgia" pitchFamily="34" charset="-122"/>
+                <a:cs typeface="Georgia" pitchFamily="34" charset="-120"/>
+              </a:rPr>
+              <a:t>Recommended Videos</a:t>
+            </a:r>
+            <a:endParaRPr lang="en-US" sz="2200" dirty="0"/>
+          </a:p>
+        </p:txBody>
+      </p:sp>
+      <p:sp>
+        <p:nvSpPr>
+          <p:cNvPr id="5" name="Text 3"/>
+          <p:cNvSpPr/>
+          <p:nvPr/>
+        </p:nvSpPr>
+        <p:spPr>
+          <a:xfrm>
+            <a:off x="640080" y="868680"/>
+            <a:ext cx="7863840" cy="274320"/>
+          </a:xfrm>
+          <a:prstGeom prst="rect">
+            <a:avLst/>
+          </a:prstGeom>
+          <a:noFill/>
+          <a:ln/>
+        </p:spPr>
+        <p:txBody>
+          <a:bodyPr wrap="square" rtlCol="0" anchor="ctr"/>
+          <a:lstStyle/>
+          <a:p>
+            <a:pPr indent="0" marL="0">
+              <a:buNone/>
+            </a:pPr>
+            <a:r>
+              <a:rPr lang="en-US" sz="1200" i="1" dirty="0">
+                <a:solidFill>
+                  <a:srgbClr val="6B6660"/>
+                </a:solidFill>
+                <a:latin typeface="Calibri" pitchFamily="34" charset="0"/>
+                <a:ea typeface="Calibri" pitchFamily="34" charset="-122"/>
+                <a:cs typeface="Calibri" pitchFamily="34" charset="-120"/>
+              </a:rPr>
+              <a:t>Search these on YouTube to learn more.</a:t>
+            </a:r>
+            <a:endParaRPr lang="en-US" sz="1200" dirty="0"/>
+          </a:p>
+        </p:txBody>
+      </p:sp>
+      <p:sp>
+        <p:nvSpPr>
+          <p:cNvPr id="6" name="Shape 4"/>
+          <p:cNvSpPr/>
+          <p:nvPr/>
+        </p:nvSpPr>
+        <p:spPr>
+          <a:xfrm>
+            <a:off x="457200" y="1234440"/>
+            <a:ext cx="8229600" cy="1051560"/>
+          </a:xfrm>
+          <a:prstGeom prst="rect">
+            <a:avLst/>
+          </a:prstGeom>
+          <a:solidFill>
+            <a:srgbClr val="FFFFFF"/>
+          </a:solidFill>
+          <a:ln/>
+          <a:effectLst>
+            <a:outerShdw sx="100000" sy="100000" kx="0" ky="0" algn="bl" rotWithShape="0" blurRad="76200" dist="25400" dir="8100000">
+              <a:srgbClr val="000000">
+                <a:alpha val="12000"/>
+              </a:srgbClr>
+            </a:outerShdw>
+          </a:effectLst>
+        </p:spPr>
+      </p:sp>
+      <p:sp>
+        <p:nvSpPr>
+          <p:cNvPr id="7" name="Shape 5"/>
+          <p:cNvSpPr/>
+          <p:nvPr/>
+        </p:nvSpPr>
+        <p:spPr>
+          <a:xfrm>
+            <a:off x="457200" y="1234440"/>
+            <a:ext cx="64008" cy="1051560"/>
+          </a:xfrm>
+          <a:prstGeom prst="rect">
+            <a:avLst/>
+          </a:prstGeom>
+          <a:solidFill>
+            <a:srgbClr val="2A9D8F"/>
+          </a:solidFill>
+          <a:ln/>
+        </p:spPr>
+      </p:sp>
+      <p:sp>
+        <p:nvSpPr>
+          <p:cNvPr id="8" name="Text 6"/>
+          <p:cNvSpPr/>
+          <p:nvPr/>
+        </p:nvSpPr>
+        <p:spPr>
+          <a:xfrm>
+            <a:off x="640080" y="1325880"/>
+            <a:ext cx="457200" cy="457200"/>
+          </a:xfrm>
+          <a:prstGeom prst="rect">
+            <a:avLst/>
+          </a:prstGeom>
+          <a:noFill/>
+          <a:ln/>
+        </p:spPr>
+        <p:txBody>
+          <a:bodyPr wrap="square" rtlCol="0" anchor="ctr"/>
+          <a:lstStyle/>
+          <a:p>
+            <a:pPr algn="ctr" indent="0" marL="0">
+              <a:buNone/>
+            </a:pPr>
+            <a:r>
+              <a:rPr lang="en-US" sz="2000" dirty="0">
+                <a:solidFill>
+                  <a:srgbClr val="2A9D8F"/>
+                </a:solidFill>
+                <a:latin typeface="Calibri" pitchFamily="34" charset="0"/>
+                <a:ea typeface="Calibri" pitchFamily="34" charset="-122"/>
+                <a:cs typeface="Calibri" pitchFamily="34" charset="-120"/>
+              </a:rPr>
+              <a:t>▶</a:t>
+            </a:r>
+            <a:endParaRPr lang="en-US" sz="2000" dirty="0"/>
+          </a:p>
+        </p:txBody>
+      </p:sp>
+      <p:sp>
+        <p:nvSpPr>
+          <p:cNvPr id="9" name="Text 7"/>
+          <p:cNvSpPr/>
+          <p:nvPr/>
+        </p:nvSpPr>
+        <p:spPr>
+          <a:xfrm>
+            <a:off x="1188720" y="1307592"/>
+            <a:ext cx="7132320" cy="411480"/>
+          </a:xfrm>
+          <a:prstGeom prst="rect">
+            <a:avLst/>
+          </a:prstGeom>
+          <a:noFill/>
+          <a:ln/>
+        </p:spPr>
+        <p:txBody>
+          <a:bodyPr wrap="square" rtlCol="0" anchor="ctr"/>
+          <a:lstStyle/>
+          <a:p>
+            <a:pPr indent="0" marL="0">
+              <a:buNone/>
+            </a:pPr>
+            <a:r>
+              <a:rPr lang="en-US" sz="1400" b="1" dirty="0">
+                <a:solidFill>
+                  <a:srgbClr val="1B2A4A"/>
+                </a:solidFill>
+                <a:latin typeface="Calibri" pitchFamily="34" charset="0"/>
+                <a:ea typeface="Calibri" pitchFamily="34" charset="-122"/>
+                <a:cs typeface="Calibri" pitchFamily="34" charset="-120"/>
+              </a:rPr>
+              <a:t>Converting Between Units of Volume and Capacity</a:t>
+            </a:r>
+            <a:endParaRPr lang="en-US" sz="1400" dirty="0"/>
+          </a:p>
+        </p:txBody>
+      </p:sp>
+      <p:sp>
+        <p:nvSpPr>
+          <p:cNvPr id="10" name="Text 8"/>
+          <p:cNvSpPr/>
+          <p:nvPr/>
+        </p:nvSpPr>
+        <p:spPr>
+          <a:xfrm>
+            <a:off x="1188720" y="1691640"/>
+            <a:ext cx="7132320" cy="320040"/>
+          </a:xfrm>
+          <a:prstGeom prst="rect">
+            <a:avLst/>
+          </a:prstGeom>
+          <a:noFill/>
+          <a:ln/>
+        </p:spPr>
+        <p:txBody>
+          <a:bodyPr wrap="square" rtlCol="0" anchor="ctr"/>
+          <a:lstStyle/>
+          <a:p>
+            <a:pPr indent="0" marL="0">
+              <a:buNone/>
+            </a:pPr>
+            <a:r>
+              <a:rPr lang="en-US" sz="1100" dirty="0">
+                <a:solidFill>
+                  <a:srgbClr val="6B6660"/>
+                </a:solidFill>
+                <a:latin typeface="Calibri" pitchFamily="34" charset="0"/>
+                <a:ea typeface="Calibri" pitchFamily="34" charset="-122"/>
+                <a:cs typeface="Calibri" pitchFamily="34" charset="-120"/>
+              </a:rPr>
+              <a:t>Corbettmaths  •  5 min</a:t>
+            </a:r>
+            <a:endParaRPr lang="en-US" sz="1100" dirty="0"/>
+          </a:p>
+        </p:txBody>
+      </p:sp>
+      <p:sp>
+        <p:nvSpPr>
+          <p:cNvPr id="11" name="Shape 9"/>
+          <p:cNvSpPr/>
+          <p:nvPr/>
+        </p:nvSpPr>
+        <p:spPr>
+          <a:xfrm>
+            <a:off x="457200" y="2423160"/>
+            <a:ext cx="8229600" cy="1051560"/>
+          </a:xfrm>
+          <a:prstGeom prst="rect">
+            <a:avLst/>
+          </a:prstGeom>
+          <a:solidFill>
+            <a:srgbClr val="FFFFFF"/>
+          </a:solidFill>
+          <a:ln/>
+          <a:effectLst>
+            <a:outerShdw sx="100000" sy="100000" kx="0" ky="0" algn="bl" rotWithShape="0" blurRad="76200" dist="25400" dir="8100000">
+              <a:srgbClr val="000000">
+                <a:alpha val="12000"/>
+              </a:srgbClr>
+            </a:outerShdw>
+          </a:effectLst>
+        </p:spPr>
+      </p:sp>
+      <p:sp>
+        <p:nvSpPr>
+          <p:cNvPr id="12" name="Shape 10"/>
+          <p:cNvSpPr/>
+          <p:nvPr/>
+        </p:nvSpPr>
+        <p:spPr>
+          <a:xfrm>
+            <a:off x="457200" y="2423160"/>
+            <a:ext cx="64008" cy="1051560"/>
+          </a:xfrm>
+          <a:prstGeom prst="rect">
+            <a:avLst/>
+          </a:prstGeom>
+          <a:solidFill>
+            <a:srgbClr val="2A9D8F"/>
+          </a:solidFill>
+          <a:ln/>
+        </p:spPr>
+      </p:sp>
+      <p:sp>
+        <p:nvSpPr>
+          <p:cNvPr id="13" name="Text 11"/>
+          <p:cNvSpPr/>
+          <p:nvPr/>
+        </p:nvSpPr>
+        <p:spPr>
+          <a:xfrm>
+            <a:off x="640080" y="2514600"/>
+            <a:ext cx="457200" cy="457200"/>
+          </a:xfrm>
+          <a:prstGeom prst="rect">
+            <a:avLst/>
+          </a:prstGeom>
+          <a:noFill/>
+          <a:ln/>
+        </p:spPr>
+        <p:txBody>
+          <a:bodyPr wrap="square" rtlCol="0" anchor="ctr"/>
+          <a:lstStyle/>
+          <a:p>
+            <a:pPr algn="ctr" indent="0" marL="0">
+              <a:buNone/>
+            </a:pPr>
+            <a:r>
+              <a:rPr lang="en-US" sz="2000" dirty="0">
+                <a:solidFill>
+                  <a:srgbClr val="2A9D8F"/>
+                </a:solidFill>
+                <a:latin typeface="Calibri" pitchFamily="34" charset="0"/>
+                <a:ea typeface="Calibri" pitchFamily="34" charset="-122"/>
+                <a:cs typeface="Calibri" pitchFamily="34" charset="-120"/>
+              </a:rPr>
+              <a:t>▶</a:t>
+            </a:r>
+            <a:endParaRPr lang="en-US" sz="2000" dirty="0"/>
+          </a:p>
+        </p:txBody>
+      </p:sp>
+      <p:sp>
+        <p:nvSpPr>
+          <p:cNvPr id="14" name="Text 12"/>
+          <p:cNvSpPr/>
+          <p:nvPr/>
+        </p:nvSpPr>
+        <p:spPr>
+          <a:xfrm>
+            <a:off x="1188720" y="2496312"/>
+            <a:ext cx="7132320" cy="411480"/>
+          </a:xfrm>
+          <a:prstGeom prst="rect">
+            <a:avLst/>
+          </a:prstGeom>
+          <a:noFill/>
+          <a:ln/>
+        </p:spPr>
+        <p:txBody>
+          <a:bodyPr wrap="square" rtlCol="0" anchor="ctr"/>
+          <a:lstStyle/>
+          <a:p>
+            <a:pPr indent="0" marL="0">
+              <a:buNone/>
+            </a:pPr>
+            <a:r>
+              <a:rPr lang="en-US" sz="1400" b="1" dirty="0">
+                <a:solidFill>
+                  <a:srgbClr val="1B2A4A"/>
+                </a:solidFill>
+                <a:latin typeface="Calibri" pitchFamily="34" charset="0"/>
+                <a:ea typeface="Calibri" pitchFamily="34" charset="-122"/>
+                <a:cs typeface="Calibri" pitchFamily="34" charset="-120"/>
+              </a:rPr>
+              <a:t>Volume and Capacity — What's the Difference?</a:t>
+            </a:r>
+            <a:endParaRPr lang="en-US" sz="1400" dirty="0"/>
+          </a:p>
+        </p:txBody>
+      </p:sp>
+      <p:sp>
+        <p:nvSpPr>
+          <p:cNvPr id="15" name="Text 13"/>
+          <p:cNvSpPr/>
+          <p:nvPr/>
+        </p:nvSpPr>
+        <p:spPr>
+          <a:xfrm>
+            <a:off x="1188720" y="2880360"/>
+            <a:ext cx="7132320" cy="320040"/>
+          </a:xfrm>
+          <a:prstGeom prst="rect">
+            <a:avLst/>
+          </a:prstGeom>
+          <a:noFill/>
+          <a:ln/>
+        </p:spPr>
+        <p:txBody>
+          <a:bodyPr wrap="square" rtlCol="0" anchor="ctr"/>
+          <a:lstStyle/>
+          <a:p>
+            <a:pPr indent="0" marL="0">
+              <a:buNone/>
+            </a:pPr>
+            <a:r>
+              <a:rPr lang="en-US" sz="1100" dirty="0">
+                <a:solidFill>
+                  <a:srgbClr val="6B6660"/>
+                </a:solidFill>
+                <a:latin typeface="Calibri" pitchFamily="34" charset="0"/>
+                <a:ea typeface="Calibri" pitchFamily="34" charset="-122"/>
+                <a:cs typeface="Calibri" pitchFamily="34" charset="-120"/>
+              </a:rPr>
+              <a:t>Math Antics  •  7 min</a:t>
+            </a:r>
+            <a:endParaRPr lang="en-US" sz="1100" dirty="0"/>
+          </a:p>
+        </p:txBody>
+      </p:sp>
+      <p:sp>
+        <p:nvSpPr>
+          <p:cNvPr id="16" name="Shape 14"/>
+          <p:cNvSpPr/>
+          <p:nvPr/>
+        </p:nvSpPr>
+        <p:spPr>
+          <a:xfrm>
+            <a:off x="457200" y="3611880"/>
+            <a:ext cx="8229600" cy="1051560"/>
+          </a:xfrm>
+          <a:prstGeom prst="rect">
+            <a:avLst/>
+          </a:prstGeom>
+          <a:solidFill>
+            <a:srgbClr val="FFFFFF"/>
+          </a:solidFill>
+          <a:ln/>
+          <a:effectLst>
+            <a:outerShdw sx="100000" sy="100000" kx="0" ky="0" algn="bl" rotWithShape="0" blurRad="76200" dist="25400" dir="8100000">
+              <a:srgbClr val="000000">
+                <a:alpha val="12000"/>
+              </a:srgbClr>
+            </a:outerShdw>
+          </a:effectLst>
+        </p:spPr>
+      </p:sp>
+      <p:sp>
+        <p:nvSpPr>
+          <p:cNvPr id="17" name="Shape 15"/>
+          <p:cNvSpPr/>
+          <p:nvPr/>
+        </p:nvSpPr>
+        <p:spPr>
+          <a:xfrm>
+            <a:off x="457200" y="3611880"/>
+            <a:ext cx="64008" cy="1051560"/>
+          </a:xfrm>
+          <a:prstGeom prst="rect">
+            <a:avLst/>
+          </a:prstGeom>
+          <a:solidFill>
+            <a:srgbClr val="2A9D8F"/>
+          </a:solidFill>
+          <a:ln/>
+        </p:spPr>
+      </p:sp>
+      <p:sp>
+        <p:nvSpPr>
+          <p:cNvPr id="18" name="Text 16"/>
+          <p:cNvSpPr/>
+          <p:nvPr/>
+        </p:nvSpPr>
+        <p:spPr>
+          <a:xfrm>
+            <a:off x="640080" y="3703320"/>
+            <a:ext cx="457200" cy="457200"/>
+          </a:xfrm>
+          <a:prstGeom prst="rect">
+            <a:avLst/>
+          </a:prstGeom>
+          <a:noFill/>
+          <a:ln/>
+        </p:spPr>
+        <p:txBody>
+          <a:bodyPr wrap="square" rtlCol="0" anchor="ctr"/>
+          <a:lstStyle/>
+          <a:p>
+            <a:pPr algn="ctr" indent="0" marL="0">
+              <a:buNone/>
+            </a:pPr>
+            <a:r>
+              <a:rPr lang="en-US" sz="2000" dirty="0">
+                <a:solidFill>
+                  <a:srgbClr val="2A9D8F"/>
+                </a:solidFill>
+                <a:latin typeface="Calibri" pitchFamily="34" charset="0"/>
+                <a:ea typeface="Calibri" pitchFamily="34" charset="-122"/>
+                <a:cs typeface="Calibri" pitchFamily="34" charset="-120"/>
+              </a:rPr>
+              <a:t>▶</a:t>
+            </a:r>
+            <a:endParaRPr lang="en-US" sz="2000" dirty="0"/>
+          </a:p>
+        </p:txBody>
+      </p:sp>
+      <p:sp>
+        <p:nvSpPr>
+          <p:cNvPr id="19" name="Text 17"/>
+          <p:cNvSpPr/>
+          <p:nvPr/>
+        </p:nvSpPr>
+        <p:spPr>
+          <a:xfrm>
+            <a:off x="1188720" y="3685032"/>
+            <a:ext cx="7132320" cy="411480"/>
+          </a:xfrm>
+          <a:prstGeom prst="rect">
+            <a:avLst/>
+          </a:prstGeom>
+          <a:noFill/>
+          <a:ln/>
+        </p:spPr>
+        <p:txBody>
+          <a:bodyPr wrap="square" rtlCol="0" anchor="ctr"/>
+          <a:lstStyle/>
+          <a:p>
+            <a:pPr indent="0" marL="0">
+              <a:buNone/>
+            </a:pPr>
+            <a:r>
+              <a:rPr lang="en-US" sz="1400" b="1" dirty="0">
+                <a:solidFill>
+                  <a:srgbClr val="1B2A4A"/>
+                </a:solidFill>
+                <a:latin typeface="Calibri" pitchFamily="34" charset="0"/>
+                <a:ea typeface="Calibri" pitchFamily="34" charset="-122"/>
+                <a:cs typeface="Calibri" pitchFamily="34" charset="-120"/>
+              </a:rPr>
+              <a:t>Metric Units of Volume — cm³, m³, litres</a:t>
+            </a:r>
+            <a:endParaRPr lang="en-US" sz="1400" dirty="0"/>
+          </a:p>
+        </p:txBody>
+      </p:sp>
+      <p:sp>
+        <p:nvSpPr>
+          <p:cNvPr id="20" name="Text 18"/>
+          <p:cNvSpPr/>
+          <p:nvPr/>
+        </p:nvSpPr>
+        <p:spPr>
+          <a:xfrm>
+            <a:off x="1188720" y="4069080"/>
+            <a:ext cx="7132320" cy="320040"/>
+          </a:xfrm>
+          <a:prstGeom prst="rect">
+            <a:avLst/>
+          </a:prstGeom>
+          <a:noFill/>
+          <a:ln/>
+        </p:spPr>
+        <p:txBody>
+          <a:bodyPr wrap="square" rtlCol="0" anchor="ctr"/>
+          <a:lstStyle/>
+          <a:p>
+            <a:pPr indent="0" marL="0">
+              <a:buNone/>
+            </a:pPr>
+            <a:r>
+              <a:rPr lang="en-US" sz="1100" dirty="0">
+                <a:solidFill>
+                  <a:srgbClr val="6B6660"/>
+                </a:solidFill>
+                <a:latin typeface="Calibri" pitchFamily="34" charset="0"/>
+                <a:ea typeface="Calibri" pitchFamily="34" charset="-122"/>
+                <a:cs typeface="Calibri" pitchFamily="34" charset="-120"/>
+              </a:rPr>
+              <a:t>Cognito  •  4 min</a:t>
+            </a:r>
+            <a:endParaRPr lang="en-US" sz="1100" dirty="0"/>
+          </a:p>
+        </p:txBody>
+      </p:sp>
+    </p:spTree>
+  </p:cSld>
+  <p:clrMapOvr>
+    <a:masterClrMapping/>
+  </p:clrMapOvr>
+</p:sld>
+</file>
+
+<file path=ppt/slides/slide8.xml><?xml version="1.0" encoding="utf-8"?>
+<p:sld xmlns:a="http://schemas.openxmlformats.org/drawingml/2006/main" xmlns:r="http://schemas.openxmlformats.org/officeDocument/2006/relationships" xmlns:p="http://schemas.openxmlformats.org/presentationml/2006/main">
+  <p:cSld name="Slide 8">
+    <p:spTree>
+      <p:nvGrpSpPr>
+        <p:cNvPr id="1" name=""/>
+        <p:cNvGrpSpPr/>
+        <p:nvPr/>
+      </p:nvGrpSpPr>
+      <p:grpSpPr>
+        <a:xfrm>
+          <a:off x="0" y="0"/>
+          <a:ext cx="0" cy="0"/>
+          <a:chOff x="0" y="0"/>
+          <a:chExt cx="0" cy="0"/>
+        </a:xfrm>
+      </p:grpSpPr>
+      <p:sp>
+        <p:nvSpPr>
+          <p:cNvPr id="2" name="Shape 0"/>
+          <p:cNvSpPr/>
+          <p:nvPr/>
+        </p:nvSpPr>
+        <p:spPr>
+          <a:xfrm>
+            <a:off x="0" y="0"/>
+            <a:ext cx="9144000" cy="5143500"/>
+          </a:xfrm>
+          <a:prstGeom prst="rect">
+            <a:avLst/>
+          </a:prstGeom>
+          <a:solidFill>
+            <a:srgbClr val="1B2A4A"/>
+          </a:solidFill>
+          <a:ln/>
+        </p:spPr>
+      </p:sp>
+      <p:sp>
+        <p:nvSpPr>
+          <p:cNvPr id="3" name="Shape 1"/>
+          <p:cNvSpPr/>
+          <p:nvPr/>
+        </p:nvSpPr>
+        <p:spPr>
+          <a:xfrm>
+            <a:off x="0" y="4777740"/>
+            <a:ext cx="9144000" cy="365760"/>
+          </a:xfrm>
+          <a:prstGeom prst="rect">
+            <a:avLst/>
+          </a:prstGeom>
+          <a:solidFill>
+            <a:srgbClr val="2A9D8F"/>
+          </a:solidFill>
+          <a:ln/>
+        </p:spPr>
+      </p:sp>
+      <p:sp>
+        <p:nvSpPr>
+          <p:cNvPr id="4" name="Text 2"/>
+          <p:cNvSpPr/>
+          <p:nvPr/>
+        </p:nvSpPr>
+        <p:spPr>
+          <a:xfrm>
+            <a:off x="731520" y="1371600"/>
+            <a:ext cx="7680960" cy="914400"/>
+          </a:xfrm>
+          <a:prstGeom prst="rect">
+            <a:avLst/>
+          </a:prstGeom>
+          <a:noFill/>
+          <a:ln/>
+        </p:spPr>
+        <p:txBody>
+          <a:bodyPr wrap="square" rtlCol="0" anchor="ctr"/>
+          <a:lstStyle/>
+          <a:p>
+            <a:pPr algn="ctr" indent="0" marL="0">
+              <a:buNone/>
+            </a:pPr>
+            <a:r>
+              <a:rPr lang="en-US" sz="3600" b="1" dirty="0">
                 <a:solidFill>
                   <a:srgbClr val="FFFFFF"/>
                 </a:solidFill>
@@ -2457,136 +4689,9 @@
                 <a:ea typeface="Georgia" pitchFamily="34" charset="-122"/>
                 <a:cs typeface="Georgia" pitchFamily="34" charset="-120"/>
               </a:rPr>
-              <a:t>Key Takeaways</a:t>
-            </a:r>
-            <a:endParaRPr lang="en-US" sz="3200" dirty="0"/>
-          </a:p>
-        </p:txBody>
-      </p:sp>
-      <p:sp>
-        <p:nvSpPr>
-          <p:cNvPr id="4" name="Text 2"/>
-          <p:cNvSpPr/>
-          <p:nvPr/>
-        </p:nvSpPr>
-        <p:spPr>
-          <a:xfrm>
-            <a:off x="731520" y="1463040"/>
-            <a:ext cx="7772400" cy="3200400"/>
-          </a:xfrm>
-          <a:prstGeom prst="rect">
-            <a:avLst/>
-          </a:prstGeom>
-          <a:noFill/>
-          <a:ln/>
-        </p:spPr>
-        <p:txBody>
-          <a:bodyPr wrap="square" rtlCol="0" anchor="t"/>
-          <a:lstStyle/>
-          <a:p>
-            <a:pPr marL="342900" indent="-342900">
-              <a:spcAft>
-                <a:spcPts val="1000"/>
-              </a:spcAft>
-              <a:buSzPct val="100000"/>
-              <a:buChar char="•"/>
-            </a:pPr>
-            <a:r>
-              <a:rPr lang="en-US" sz="1500" dirty="0">
-                <a:solidFill>
-                  <a:srgbClr val="CADCFC"/>
-                </a:solidFill>
-                <a:latin typeface="Calibri" pitchFamily="34" charset="0"/>
-                <a:ea typeface="Calibri" pitchFamily="34" charset="-122"/>
-                <a:cs typeface="Calibri" pitchFamily="34" charset="-120"/>
-              </a:rPr>
-              <a:t>Capacity = maximum a container can hold (L, mL)</a:t>
-            </a:r>
-            <a:endParaRPr lang="en-US" sz="1500" dirty="0"/>
-          </a:p>
-          <a:p>
-            <a:pPr marL="342900" indent="-342900">
-              <a:spcAft>
-                <a:spcPts val="1000"/>
-              </a:spcAft>
-              <a:buSzPct val="100000"/>
-              <a:buChar char="•"/>
-            </a:pPr>
-            <a:r>
-              <a:rPr lang="en-US" sz="1500" dirty="0">
-                <a:solidFill>
-                  <a:srgbClr val="CADCFC"/>
-                </a:solidFill>
-                <a:latin typeface="Calibri" pitchFamily="34" charset="0"/>
-                <a:ea typeface="Calibri" pitchFamily="34" charset="-122"/>
-                <a:cs typeface="Calibri" pitchFamily="34" charset="-120"/>
-              </a:rPr>
-              <a:t>1 cm³ = 1 mL. 1000 cm³ = 1 L. 1 m³ = 1000 L</a:t>
-            </a:r>
-            <a:endParaRPr lang="en-US" sz="1500" dirty="0"/>
-          </a:p>
-          <a:p>
-            <a:pPr marL="342900" indent="-342900">
-              <a:spcAft>
-                <a:spcPts val="1000"/>
-              </a:spcAft>
-              <a:buSzPct val="100000"/>
-              <a:buChar char="•"/>
-            </a:pPr>
-            <a:r>
-              <a:rPr lang="en-US" sz="1500" dirty="0">
-                <a:solidFill>
-                  <a:srgbClr val="CADCFC"/>
-                </a:solidFill>
-                <a:latin typeface="Calibri" pitchFamily="34" charset="0"/>
-                <a:ea typeface="Calibri" pitchFamily="34" charset="-122"/>
-                <a:cs typeface="Calibri" pitchFamily="34" charset="-120"/>
-              </a:rPr>
-              <a:t>Calculate volume of container, then convert to capacity</a:t>
-            </a:r>
-            <a:endParaRPr lang="en-US" sz="1500" dirty="0"/>
-          </a:p>
-          <a:p>
-            <a:pPr marL="342900" indent="-342900">
-              <a:spcAft>
-                <a:spcPts val="1000"/>
-              </a:spcAft>
-              <a:buSzPct val="100000"/>
-              <a:buChar char="•"/>
-            </a:pPr>
-            <a:r>
-              <a:rPr lang="en-US" sz="1500" dirty="0">
-                <a:solidFill>
-                  <a:srgbClr val="CADCFC"/>
-                </a:solidFill>
-                <a:latin typeface="Calibri" pitchFamily="34" charset="0"/>
-                <a:ea typeface="Calibri" pitchFamily="34" charset="-122"/>
-                <a:cs typeface="Calibri" pitchFamily="34" charset="-120"/>
-              </a:rPr>
-              <a:t>Read measuring cylinders at eye level, bottom of meniscus</a:t>
-            </a:r>
-            <a:endParaRPr lang="en-US" sz="1500" dirty="0"/>
-          </a:p>
-          <a:p>
-            <a:pPr marL="342900" indent="-342900">
-              <a:spcAft>
-                <a:spcPts val="1000"/>
-              </a:spcAft>
-              <a:buSzPct val="100000"/>
-              <a:buChar char="•"/>
-            </a:pPr>
-            <a:r>
-              <a:rPr lang="en-US" sz="1500" dirty="0">
-                <a:solidFill>
-                  <a:srgbClr val="CADCFC"/>
-                </a:solidFill>
-                <a:latin typeface="Calibri" pitchFamily="34" charset="0"/>
-                <a:ea typeface="Calibri" pitchFamily="34" charset="-122"/>
-                <a:cs typeface="Calibri" pitchFamily="34" charset="-120"/>
-              </a:rPr>
-              <a:t>Real-world: fish tanks, pools, jugs — always convert units first</a:t>
-            </a:r>
-            <a:endParaRPr lang="en-US" sz="1500" dirty="0"/>
+              <a:t>Review &amp; Practise</a:t>
+            </a:r>
+            <a:endParaRPr lang="en-US" sz="3600" dirty="0"/>
           </a:p>
         </p:txBody>
       </p:sp>
@@ -2598,8 +4703,8 @@
         </p:nvSpPr>
         <p:spPr>
           <a:xfrm>
-            <a:off x="731520" y="4572000"/>
-            <a:ext cx="7772400" cy="365760"/>
+            <a:off x="731520" y="2560320"/>
+            <a:ext cx="7680960" cy="548640"/>
           </a:xfrm>
           <a:prstGeom prst="rect">
             <a:avLst/>
@@ -2611,13 +4716,13 @@
           <a:bodyPr wrap="square" rtlCol="0" anchor="ctr"/>
           <a:lstStyle/>
           <a:p>
-            <a:pPr indent="0" marL="0">
+            <a:pPr algn="ctr" indent="0" marL="0">
               <a:buNone/>
             </a:pPr>
             <a:r>
-              <a:rPr lang="en-US" sz="1100" dirty="0">
+              <a:rPr lang="en-US" sz="2000" dirty="0">
                 <a:solidFill>
-                  <a:srgbClr val="E9C46A"/>
+                  <a:srgbClr val="2A9D8F"/>
                 </a:solidFill>
                 <a:latin typeface="Calibri" pitchFamily="34" charset="0"/>
                 <a:ea typeface="Calibri" pitchFamily="34" charset="-122"/>
@@ -2625,7 +4730,7 @@
               </a:rPr>
               <a:t>mrzocchi.com</a:t>
             </a:r>
-            <a:endParaRPr lang="en-US" sz="1100" dirty="0"/>
+            <a:endParaRPr lang="en-US" sz="2000" dirty="0"/>
           </a:p>
         </p:txBody>
       </p:sp>

</xml_diff>